<commit_message>
Update slides_7.pptx to further refine content and visuals for the upcoming lecture.
</commit_message>
<xml_diff>
--- a/lectures/slides_7.pptx
+++ b/lectures/slides_7.pptx
@@ -5,7 +5,7 @@
     <p:sldMasterId id="2147483659" r:id="rId1"/>
   </p:sldMasterIdLst>
   <p:notesMasterIdLst>
-    <p:notesMasterId r:id="rId98"/>
+    <p:notesMasterId r:id="rId96"/>
   </p:notesMasterIdLst>
   <p:sldIdLst>
     <p:sldId id="258" r:id="rId2"/>
@@ -80,30 +80,28 @@
     <p:sldId id="328" r:id="rId71"/>
     <p:sldId id="329" r:id="rId72"/>
     <p:sldId id="330" r:id="rId73"/>
-    <p:sldId id="331" r:id="rId74"/>
-    <p:sldId id="332" r:id="rId75"/>
-    <p:sldId id="333" r:id="rId76"/>
-    <p:sldId id="334" r:id="rId77"/>
-    <p:sldId id="335" r:id="rId78"/>
-    <p:sldId id="336" r:id="rId79"/>
-    <p:sldId id="337" r:id="rId80"/>
-    <p:sldId id="338" r:id="rId81"/>
-    <p:sldId id="339" r:id="rId82"/>
-    <p:sldId id="340" r:id="rId83"/>
-    <p:sldId id="341" r:id="rId84"/>
-    <p:sldId id="342" r:id="rId85"/>
-    <p:sldId id="343" r:id="rId86"/>
-    <p:sldId id="344" r:id="rId87"/>
-    <p:sldId id="345" r:id="rId88"/>
-    <p:sldId id="346" r:id="rId89"/>
-    <p:sldId id="347" r:id="rId90"/>
-    <p:sldId id="348" r:id="rId91"/>
-    <p:sldId id="349" r:id="rId92"/>
-    <p:sldId id="350" r:id="rId93"/>
-    <p:sldId id="351" r:id="rId94"/>
-    <p:sldId id="352" r:id="rId95"/>
-    <p:sldId id="353" r:id="rId96"/>
-    <p:sldId id="354" r:id="rId97"/>
+    <p:sldId id="332" r:id="rId74"/>
+    <p:sldId id="333" r:id="rId75"/>
+    <p:sldId id="334" r:id="rId76"/>
+    <p:sldId id="335" r:id="rId77"/>
+    <p:sldId id="336" r:id="rId78"/>
+    <p:sldId id="338" r:id="rId79"/>
+    <p:sldId id="339" r:id="rId80"/>
+    <p:sldId id="340" r:id="rId81"/>
+    <p:sldId id="341" r:id="rId82"/>
+    <p:sldId id="342" r:id="rId83"/>
+    <p:sldId id="343" r:id="rId84"/>
+    <p:sldId id="344" r:id="rId85"/>
+    <p:sldId id="345" r:id="rId86"/>
+    <p:sldId id="346" r:id="rId87"/>
+    <p:sldId id="347" r:id="rId88"/>
+    <p:sldId id="348" r:id="rId89"/>
+    <p:sldId id="349" r:id="rId90"/>
+    <p:sldId id="350" r:id="rId91"/>
+    <p:sldId id="351" r:id="rId92"/>
+    <p:sldId id="352" r:id="rId93"/>
+    <p:sldId id="353" r:id="rId94"/>
+    <p:sldId id="354" r:id="rId95"/>
   </p:sldIdLst>
   <p:sldSz cx="9144000" cy="5143500" type="screen16x9"/>
   <p:notesSz cx="6858000" cy="9144000"/>
@@ -6170,7 +6168,7 @@
         </p:nvSpPr>
         <p:spPr>
           <a:xfrm>
-            <a:off x="381300" y="685800"/>
+            <a:off x="381000" y="685800"/>
             <a:ext cx="6096000" cy="3429000"/>
           </a:xfrm>
           <a:custGeom>
@@ -6233,7 +6231,38 @@
               </a:spcAft>
               <a:buNone/>
             </a:pPr>
-            <a:endParaRPr/>
+            <a:r>
+              <a:rPr lang="en-GB" dirty="0"/>
+              <a:t>Simpler, but colon</a:t>
+            </a:r>
+          </a:p>
+          <a:p>
+            <a:pPr marL="0" lvl="0" indent="0" algn="l" rtl="0">
+              <a:spcBef>
+                <a:spcPts val="0"/>
+              </a:spcBef>
+              <a:spcAft>
+                <a:spcPts val="0"/>
+              </a:spcAft>
+              <a:buNone/>
+            </a:pPr>
+            <a:endParaRPr lang="en-GB" dirty="0"/>
+          </a:p>
+          <a:p>
+            <a:pPr marL="0" lvl="0" indent="0" algn="l" rtl="0">
+              <a:spcBef>
+                <a:spcPts val="0"/>
+              </a:spcBef>
+              <a:spcAft>
+                <a:spcPts val="0"/>
+              </a:spcAft>
+              <a:buNone/>
+            </a:pPr>
+            <a:r>
+              <a:rPr lang="en-GB" dirty="0"/>
+              <a:t>NB indentation matters! (4 spaces)</a:t>
+            </a:r>
+            <a:endParaRPr dirty="0"/>
           </a:p>
         </p:txBody>
       </p:sp>
@@ -6495,7 +6524,7 @@
         </p:nvSpPr>
         <p:spPr>
           <a:xfrm>
-            <a:off x="381300" y="685800"/>
+            <a:off x="381000" y="685800"/>
             <a:ext cx="6096000" cy="3429000"/>
           </a:xfrm>
           <a:custGeom>
@@ -6558,7 +6587,11 @@
               </a:spcAft>
               <a:buNone/>
             </a:pPr>
-            <a:endParaRPr/>
+            <a:r>
+              <a:rPr lang="en-GB" dirty="0"/>
+              <a:t>In python</a:t>
+            </a:r>
+            <a:endParaRPr dirty="0"/>
           </a:p>
         </p:txBody>
       </p:sp>
@@ -7060,7 +7093,7 @@
         </p:nvSpPr>
         <p:spPr>
           <a:xfrm>
-            <a:off x="381300" y="685800"/>
+            <a:off x="381000" y="685800"/>
             <a:ext cx="6096000" cy="3429000"/>
           </a:xfrm>
           <a:custGeom>
@@ -7124,14 +7157,14 @@
               <a:buNone/>
             </a:pPr>
             <a:r>
-              <a:rPr lang="en">
+              <a:rPr lang="en" dirty="0">
                 <a:solidFill>
                   <a:schemeClr val="dk1"/>
                 </a:solidFill>
               </a:rPr>
               <a:t>4/compare.py</a:t>
             </a:r>
-            <a:endParaRPr>
+            <a:endParaRPr dirty="0">
               <a:solidFill>
                 <a:schemeClr val="dk1"/>
               </a:solidFill>
@@ -7148,14 +7181,57 @@
               <a:buNone/>
             </a:pPr>
             <a:r>
-              <a:rPr lang="en">
+              <a:rPr lang="en" dirty="0">
                 <a:solidFill>
                   <a:schemeClr val="dk1"/>
                 </a:solidFill>
               </a:rPr>
               <a:t>1/agree{0,1}.py</a:t>
             </a:r>
-            <a:endParaRPr/>
+          </a:p>
+          <a:p>
+            <a:pPr marL="0" lvl="0" indent="0" algn="l" rtl="0">
+              <a:spcBef>
+                <a:spcPts val="0"/>
+              </a:spcBef>
+              <a:spcAft>
+                <a:spcPts val="0"/>
+              </a:spcAft>
+              <a:buNone/>
+            </a:pPr>
+            <a:endParaRPr lang="en" dirty="0">
+              <a:solidFill>
+                <a:schemeClr val="dk1"/>
+              </a:solidFill>
+            </a:endParaRPr>
+          </a:p>
+          <a:p>
+            <a:pPr marL="0" lvl="0" indent="0" algn="l" rtl="0">
+              <a:spcBef>
+                <a:spcPts val="0"/>
+              </a:spcBef>
+              <a:spcAft>
+                <a:spcPts val="0"/>
+              </a:spcAft>
+              <a:buNone/>
+            </a:pPr>
+            <a:r>
+              <a:rPr lang="en-GB" dirty="0">
+                <a:solidFill>
+                  <a:schemeClr val="dk1"/>
+                </a:solidFill>
+              </a:rPr>
+              <a:t>N</a:t>
+            </a:r>
+            <a:r>
+              <a:rPr lang="en" dirty="0">
+                <a:solidFill>
+                  <a:schemeClr val="dk1"/>
+                </a:solidFill>
+              </a:rPr>
+              <a:t>otes and examples</a:t>
+            </a:r>
+            <a:endParaRPr dirty="0"/>
           </a:p>
         </p:txBody>
       </p:sp>
@@ -7196,7 +7272,7 @@
         </p:nvSpPr>
         <p:spPr>
           <a:xfrm>
-            <a:off x="381300" y="685800"/>
+            <a:off x="381000" y="685800"/>
             <a:ext cx="6096000" cy="3429000"/>
           </a:xfrm>
           <a:custGeom>
@@ -7259,7 +7335,136 @@
               </a:spcAft>
               <a:buNone/>
             </a:pPr>
-            <a:endParaRPr>
+            <a:r>
+              <a:rPr lang="en-GB" dirty="0">
+                <a:solidFill>
+                  <a:schemeClr val="dk1"/>
+                </a:solidFill>
+              </a:rPr>
+              <a:t>“OOP”</a:t>
+            </a:r>
+          </a:p>
+          <a:p>
+            <a:pPr marL="0" lvl="0" indent="0" algn="l" rtl="0">
+              <a:spcBef>
+                <a:spcPts val="0"/>
+              </a:spcBef>
+              <a:spcAft>
+                <a:spcPts val="0"/>
+              </a:spcAft>
+              <a:buNone/>
+            </a:pPr>
+            <a:endParaRPr lang="en-GB" dirty="0">
+              <a:solidFill>
+                <a:schemeClr val="dk1"/>
+              </a:solidFill>
+            </a:endParaRPr>
+          </a:p>
+          <a:p>
+            <a:pPr marL="0" lvl="0" indent="0" algn="l" rtl="0">
+              <a:spcBef>
+                <a:spcPts val="0"/>
+              </a:spcBef>
+              <a:spcAft>
+                <a:spcPts val="0"/>
+              </a:spcAft>
+              <a:buNone/>
+            </a:pPr>
+            <a:r>
+              <a:rPr lang="en-GB" dirty="0">
+                <a:solidFill>
+                  <a:schemeClr val="dk1"/>
+                </a:solidFill>
+              </a:rPr>
+              <a:t>Instead of structs in c you have objects of a particular class</a:t>
+            </a:r>
+          </a:p>
+          <a:p>
+            <a:pPr marL="0" lvl="0" indent="0" algn="l" rtl="0">
+              <a:spcBef>
+                <a:spcPts val="0"/>
+              </a:spcBef>
+              <a:spcAft>
+                <a:spcPts val="0"/>
+              </a:spcAft>
+              <a:buNone/>
+            </a:pPr>
+            <a:endParaRPr lang="en-GB" dirty="0">
+              <a:solidFill>
+                <a:schemeClr val="dk1"/>
+              </a:solidFill>
+            </a:endParaRPr>
+          </a:p>
+          <a:p>
+            <a:pPr marL="0" lvl="0" indent="0" algn="l" rtl="0">
+              <a:spcBef>
+                <a:spcPts val="0"/>
+              </a:spcBef>
+              <a:spcAft>
+                <a:spcPts val="0"/>
+              </a:spcAft>
+              <a:buNone/>
+            </a:pPr>
+            <a:r>
+              <a:rPr lang="en-GB" dirty="0">
+                <a:solidFill>
+                  <a:schemeClr val="dk1"/>
+                </a:solidFill>
+              </a:rPr>
+              <a:t>Implements structs with functionality as an element of good style</a:t>
+            </a:r>
+          </a:p>
+          <a:p>
+            <a:pPr marL="0" lvl="0" indent="0" algn="l" rtl="0">
+              <a:spcBef>
+                <a:spcPts val="0"/>
+              </a:spcBef>
+              <a:spcAft>
+                <a:spcPts val="0"/>
+              </a:spcAft>
+              <a:buNone/>
+            </a:pPr>
+            <a:endParaRPr lang="en-GB" dirty="0">
+              <a:solidFill>
+                <a:schemeClr val="dk1"/>
+              </a:solidFill>
+            </a:endParaRPr>
+          </a:p>
+          <a:p>
+            <a:pPr marL="0" lvl="0" indent="0" algn="l" rtl="0">
+              <a:spcBef>
+                <a:spcPts val="0"/>
+              </a:spcBef>
+              <a:spcAft>
+                <a:spcPts val="0"/>
+              </a:spcAft>
+              <a:buNone/>
+            </a:pPr>
+            <a:r>
+              <a:rPr lang="en-GB" dirty="0">
+                <a:solidFill>
+                  <a:schemeClr val="dk1"/>
+                </a:solidFill>
+              </a:rPr>
+              <a:t>If functions in python are associated with particular data, they are called “methods”, like </a:t>
+            </a:r>
+            <a:r>
+              <a:rPr lang="en-GB" dirty="0" err="1">
+                <a:solidFill>
+                  <a:schemeClr val="dk1"/>
+                </a:solidFill>
+              </a:rPr>
+              <a:t>s.lower</a:t>
+            </a:r>
+            <a:r>
+              <a:rPr lang="en-GB" dirty="0">
+                <a:solidFill>
+                  <a:schemeClr val="dk1"/>
+                </a:solidFill>
+              </a:rPr>
+              <a:t>()</a:t>
+            </a:r>
+            <a:endParaRPr dirty="0">
               <a:solidFill>
                 <a:schemeClr val="dk1"/>
               </a:solidFill>
@@ -8512,7 +8717,7 @@
         </p:nvSpPr>
         <p:spPr>
           <a:xfrm>
-            <a:off x="381300" y="685800"/>
+            <a:off x="381000" y="685800"/>
             <a:ext cx="6096000" cy="3429000"/>
           </a:xfrm>
           <a:custGeom>
@@ -8575,7 +8780,11 @@
               </a:spcAft>
               <a:buNone/>
             </a:pPr>
-            <a:endParaRPr/>
+            <a:r>
+              <a:rPr lang="en-GB" dirty="0"/>
+              <a:t>Problem with lots of iterations!</a:t>
+            </a:r>
+            <a:endParaRPr dirty="0"/>
           </a:p>
         </p:txBody>
       </p:sp>
@@ -8720,7 +8929,7 @@
         </p:nvSpPr>
         <p:spPr>
           <a:xfrm>
-            <a:off x="381300" y="685800"/>
+            <a:off x="381000" y="685800"/>
             <a:ext cx="6096000" cy="3429000"/>
           </a:xfrm>
           <a:custGeom>
@@ -8783,7 +8992,11 @@
               </a:spcAft>
               <a:buNone/>
             </a:pPr>
-            <a:endParaRPr/>
+            <a:r>
+              <a:rPr lang="en-GB" dirty="0"/>
+              <a:t>Underscore style if not actually using loop var</a:t>
+            </a:r>
+            <a:endParaRPr dirty="0"/>
           </a:p>
         </p:txBody>
       </p:sp>
@@ -8800,7 +9013,7 @@
   <p:cSld>
     <p:spTree>
       <p:nvGrpSpPr>
-        <p:cNvPr id="1" name="Shape 526"/>
+        <p:cNvPr id="1" name="Shape 531"/>
         <p:cNvGrpSpPr/>
         <p:nvPr/>
       </p:nvGrpSpPr>
@@ -8814,7 +9027,7 @@
       </p:grpSpPr>
       <p:sp>
         <p:nvSpPr>
-          <p:cNvPr id="527" name="Google Shape;527;g2d48d6721ca_1_40:notes"/>
+          <p:cNvPr id="532" name="Google Shape;532;g14119545db0_0_327:notes"/>
           <p:cNvSpPr>
             <a:spLocks noGrp="1" noRot="1" noChangeAspect="1"/>
           </p:cNvSpPr>
@@ -8855,7 +9068,7 @@
       </p:sp>
       <p:sp>
         <p:nvSpPr>
-          <p:cNvPr id="528" name="Google Shape;528;g2d48d6721ca_1_40:notes"/>
+          <p:cNvPr id="533" name="Google Shape;533;g14119545db0_0_327:notes"/>
           <p:cNvSpPr txBox="1">
             <a:spLocks noGrp="1"/>
           </p:cNvSpPr>
@@ -8887,6 +9100,19 @@
               </a:spcAft>
               <a:buNone/>
             </a:pPr>
+            <a:r>
+              <a:rPr lang="en" u="sng">
+                <a:solidFill>
+                  <a:schemeClr val="hlink"/>
+                </a:solidFill>
+                <a:hlinkClick r:id="rId3"/>
+              </a:rPr>
+              <a:t>https://scratchblocks.github.io/#?style=scratch3&amp;script=forever%0Asay%5Bmeow%5D</a:t>
+            </a:r>
+            <a:r>
+              <a:rPr lang="en"/>
+              <a:t> </a:t>
+            </a:r>
             <a:endParaRPr/>
           </a:p>
         </p:txBody>
@@ -8904,7 +9130,7 @@
   <p:cSld>
     <p:spTree>
       <p:nvGrpSpPr>
-        <p:cNvPr id="1" name="Shape 531"/>
+        <p:cNvPr id="1" name="Shape 539"/>
         <p:cNvGrpSpPr/>
         <p:nvPr/>
       </p:nvGrpSpPr>
@@ -8918,7 +9144,7 @@
       </p:grpSpPr>
       <p:sp>
         <p:nvSpPr>
-          <p:cNvPr id="532" name="Google Shape;532;g14119545db0_0_327:notes"/>
+          <p:cNvPr id="540" name="Google Shape;540;g14119545db0_0_334:notes"/>
           <p:cNvSpPr>
             <a:spLocks noGrp="1" noRot="1" noChangeAspect="1"/>
           </p:cNvSpPr>
@@ -8959,7 +9185,7 @@
       </p:sp>
       <p:sp>
         <p:nvSpPr>
-          <p:cNvPr id="533" name="Google Shape;533;g14119545db0_0_327:notes"/>
+          <p:cNvPr id="541" name="Google Shape;541;g14119545db0_0_334:notes"/>
           <p:cNvSpPr txBox="1">
             <a:spLocks noGrp="1"/>
           </p:cNvSpPr>
@@ -8991,19 +9217,6 @@
               </a:spcAft>
               <a:buNone/>
             </a:pPr>
-            <a:r>
-              <a:rPr lang="en" u="sng">
-                <a:solidFill>
-                  <a:schemeClr val="hlink"/>
-                </a:solidFill>
-                <a:hlinkClick r:id="rId3"/>
-              </a:rPr>
-              <a:t>https://scratchblocks.github.io/#?style=scratch3&amp;script=forever%0Asay%5Bmeow%5D</a:t>
-            </a:r>
-            <a:r>
-              <a:rPr lang="en"/>
-              <a:t> </a:t>
-            </a:r>
             <a:endParaRPr/>
           </a:p>
         </p:txBody>
@@ -9021,7 +9234,7 @@
   <p:cSld>
     <p:spTree>
       <p:nvGrpSpPr>
-        <p:cNvPr id="1" name="Shape 539"/>
+        <p:cNvPr id="1" name="Shape 547"/>
         <p:cNvGrpSpPr/>
         <p:nvPr/>
       </p:nvGrpSpPr>
@@ -9035,7 +9248,7 @@
       </p:grpSpPr>
       <p:sp>
         <p:nvSpPr>
-          <p:cNvPr id="540" name="Google Shape;540;g14119545db0_0_334:notes"/>
+          <p:cNvPr id="548" name="Google Shape;548;g14119545db0_0_341:notes"/>
           <p:cNvSpPr>
             <a:spLocks noGrp="1" noRot="1" noChangeAspect="1"/>
           </p:cNvSpPr>
@@ -9076,7 +9289,7 @@
       </p:sp>
       <p:sp>
         <p:nvSpPr>
-          <p:cNvPr id="541" name="Google Shape;541;g14119545db0_0_334:notes"/>
+          <p:cNvPr id="549" name="Google Shape;549;g14119545db0_0_341:notes"/>
           <p:cNvSpPr txBox="1">
             <a:spLocks noGrp="1"/>
           </p:cNvSpPr>
@@ -9108,6 +9321,14 @@
               </a:spcAft>
               <a:buNone/>
             </a:pPr>
+            <a:r>
+              <a:rPr lang="en">
+                <a:solidFill>
+                  <a:schemeClr val="dk1"/>
+                </a:solidFill>
+              </a:rPr>
+              <a:t>meow{0,1,2,3,4,5,6}.py</a:t>
+            </a:r>
             <a:endParaRPr/>
           </a:p>
         </p:txBody>
@@ -9125,7 +9346,7 @@
   <p:cSld>
     <p:spTree>
       <p:nvGrpSpPr>
-        <p:cNvPr id="1" name="Shape 547"/>
+        <p:cNvPr id="1" name="Shape 555"/>
         <p:cNvGrpSpPr/>
         <p:nvPr/>
       </p:nvGrpSpPr>
@@ -9139,7 +9360,7 @@
       </p:grpSpPr>
       <p:sp>
         <p:nvSpPr>
-          <p:cNvPr id="548" name="Google Shape;548;g14119545db0_0_341:notes"/>
+          <p:cNvPr id="556" name="Google Shape;556;g29255e19e45_7_0:notes"/>
           <p:cNvSpPr>
             <a:spLocks noGrp="1" noRot="1" noChangeAspect="1"/>
           </p:cNvSpPr>
@@ -9149,7 +9370,7 @@
         </p:nvSpPr>
         <p:spPr>
           <a:xfrm>
-            <a:off x="381300" y="685800"/>
+            <a:off x="381000" y="685800"/>
             <a:ext cx="6096000" cy="3429000"/>
           </a:xfrm>
           <a:custGeom>
@@ -9180,7 +9401,7 @@
       </p:sp>
       <p:sp>
         <p:nvSpPr>
-          <p:cNvPr id="549" name="Google Shape;549;g14119545db0_0_341:notes"/>
+          <p:cNvPr id="557" name="Google Shape;557;g29255e19e45_7_0:notes"/>
           <p:cNvSpPr txBox="1">
             <a:spLocks noGrp="1"/>
           </p:cNvSpPr>
@@ -9213,14 +9434,73 @@
               <a:buNone/>
             </a:pPr>
             <a:r>
-              <a:rPr lang="en">
+              <a:rPr lang="en" dirty="0"/>
+              <a:t>calculator2.py, with 1/3</a:t>
+            </a:r>
+            <a:endParaRPr dirty="0"/>
+          </a:p>
+          <a:p>
+            <a:pPr marL="0" lvl="0" indent="0" algn="l" rtl="0">
+              <a:spcBef>
+                <a:spcPts val="0"/>
+              </a:spcBef>
+              <a:spcAft>
+                <a:spcPts val="0"/>
+              </a:spcAft>
+              <a:buNone/>
+            </a:pPr>
+            <a:r>
+              <a:rPr lang="en" dirty="0">
                 <a:solidFill>
                   <a:schemeClr val="dk1"/>
                 </a:solidFill>
               </a:rPr>
-              <a:t>meow{0,1,2,3,4,5,6}.py</a:t>
+              <a:t>not an issue with /</a:t>
             </a:r>
-            <a:endParaRPr/>
+          </a:p>
+          <a:p>
+            <a:pPr marL="0" lvl="0" indent="0" algn="l" rtl="0">
+              <a:spcBef>
+                <a:spcPts val="0"/>
+              </a:spcBef>
+              <a:spcAft>
+                <a:spcPts val="0"/>
+              </a:spcAft>
+              <a:buNone/>
+            </a:pPr>
+            <a:endParaRPr lang="en" dirty="0">
+              <a:solidFill>
+                <a:schemeClr val="dk1"/>
+              </a:solidFill>
+            </a:endParaRPr>
+          </a:p>
+          <a:p>
+            <a:pPr marL="0" lvl="0" indent="0" algn="l" rtl="0">
+              <a:spcBef>
+                <a:spcPts val="0"/>
+              </a:spcBef>
+              <a:spcAft>
+                <a:spcPts val="0"/>
+              </a:spcAft>
+              <a:buNone/>
+            </a:pPr>
+            <a:r>
+              <a:rPr lang="en-GB" dirty="0">
+                <a:solidFill>
+                  <a:schemeClr val="dk1"/>
+                </a:solidFill>
+              </a:rPr>
+              <a:t>D</a:t>
+            </a:r>
+            <a:r>
+              <a:rPr lang="en" dirty="0">
+                <a:solidFill>
+                  <a:schemeClr val="dk1"/>
+                </a:solidFill>
+              </a:rPr>
+              <a:t>ivision with ints and floats mathematical outcomes – no truncation!!!</a:t>
+            </a:r>
+            <a:endParaRPr dirty="0"/>
           </a:p>
         </p:txBody>
       </p:sp>
@@ -9237,7 +9517,7 @@
   <p:cSld>
     <p:spTree>
       <p:nvGrpSpPr>
-        <p:cNvPr id="1" name="Shape 555"/>
+        <p:cNvPr id="1" name="Shape 560"/>
         <p:cNvGrpSpPr/>
         <p:nvPr/>
       </p:nvGrpSpPr>
@@ -9251,7 +9531,7 @@
       </p:grpSpPr>
       <p:sp>
         <p:nvSpPr>
-          <p:cNvPr id="556" name="Google Shape;556;g29255e19e45_7_0:notes"/>
+          <p:cNvPr id="561" name="Google Shape;561;g14119545db0_0_400:notes"/>
           <p:cNvSpPr>
             <a:spLocks noGrp="1" noRot="1" noChangeAspect="1"/>
           </p:cNvSpPr>
@@ -9292,7 +9572,7 @@
       </p:sp>
       <p:sp>
         <p:nvSpPr>
-          <p:cNvPr id="557" name="Google Shape;557;g29255e19e45_7_0:notes"/>
+          <p:cNvPr id="562" name="Google Shape;562;g14119545db0_0_400:notes"/>
           <p:cNvSpPr txBox="1">
             <a:spLocks noGrp="1"/>
           </p:cNvSpPr>
@@ -9302,7 +9582,7 @@
         </p:nvSpPr>
         <p:spPr>
           <a:xfrm>
-            <a:off x="685800" y="4343400"/>
+            <a:off x="685800" y="4495800"/>
             <a:ext cx="5486400" cy="4114800"/>
           </a:xfrm>
           <a:prstGeom prst="rect">
@@ -9314,22 +9594,6 @@
             <a:noAutofit/>
           </a:bodyPr>
           <a:lstStyle/>
-          <a:p>
-            <a:pPr marL="0" lvl="0" indent="0" algn="l" rtl="0">
-              <a:spcBef>
-                <a:spcPts val="0"/>
-              </a:spcBef>
-              <a:spcAft>
-                <a:spcPts val="0"/>
-              </a:spcAft>
-              <a:buNone/>
-            </a:pPr>
-            <a:r>
-              <a:rPr lang="en"/>
-              <a:t>calculator2.py, with 1/3</a:t>
-            </a:r>
-            <a:endParaRPr/>
-          </a:p>
           <a:p>
             <a:pPr marL="0" lvl="0" indent="0" algn="l" rtl="0">
               <a:spcBef>
@@ -9346,9 +9610,13 @@
                   <a:schemeClr val="dk1"/>
                 </a:solidFill>
               </a:rPr>
-              <a:t>not an issue with /</a:t>
+              <a:t>calculator3.py, with 1/3</a:t>
             </a:r>
-            <a:endParaRPr/>
+            <a:endParaRPr>
+              <a:solidFill>
+                <a:schemeClr val="dk1"/>
+              </a:solidFill>
+            </a:endParaRPr>
           </a:p>
         </p:txBody>
       </p:sp>
@@ -9365,7 +9633,7 @@
   <p:cSld>
     <p:spTree>
       <p:nvGrpSpPr>
-        <p:cNvPr id="1" name="Shape 560"/>
+        <p:cNvPr id="1" name="Shape 570"/>
         <p:cNvGrpSpPr/>
         <p:nvPr/>
       </p:nvGrpSpPr>
@@ -9379,7 +9647,7 @@
       </p:grpSpPr>
       <p:sp>
         <p:nvSpPr>
-          <p:cNvPr id="561" name="Google Shape;561;g14119545db0_0_400:notes"/>
+          <p:cNvPr id="571" name="Google Shape;571;g2922c153d14_0_214:notes"/>
           <p:cNvSpPr>
             <a:spLocks noGrp="1" noRot="1" noChangeAspect="1"/>
           </p:cNvSpPr>
@@ -9389,7 +9657,7 @@
         </p:nvSpPr>
         <p:spPr>
           <a:xfrm>
-            <a:off x="381300" y="685800"/>
+            <a:off x="381000" y="685800"/>
             <a:ext cx="6096000" cy="3429000"/>
           </a:xfrm>
           <a:custGeom>
@@ -9420,7 +9688,7 @@
       </p:sp>
       <p:sp>
         <p:nvSpPr>
-          <p:cNvPr id="562" name="Google Shape;562;g14119545db0_0_400:notes"/>
+          <p:cNvPr id="572" name="Google Shape;572;g2922c153d14_0_214:notes"/>
           <p:cNvSpPr txBox="1">
             <a:spLocks noGrp="1"/>
           </p:cNvSpPr>
@@ -9430,7 +9698,7 @@
         </p:nvSpPr>
         <p:spPr>
           <a:xfrm>
-            <a:off x="685800" y="4495800"/>
+            <a:off x="685800" y="4343400"/>
             <a:ext cx="5486400" cy="4114800"/>
           </a:xfrm>
           <a:prstGeom prst="rect">
@@ -9453,18 +9721,72 @@
               <a:buNone/>
             </a:pPr>
             <a:r>
-              <a:rPr lang="en">
-                <a:solidFill>
-                  <a:schemeClr val="dk1"/>
-                </a:solidFill>
-              </a:rPr>
-              <a:t>calculator3.py, with 1/3</a:t>
+              <a:rPr lang="en" dirty="0"/>
+              <a:t>integer{0,1,2,3,4}.py</a:t>
             </a:r>
-            <a:endParaRPr>
-              <a:solidFill>
-                <a:schemeClr val="dk1"/>
-              </a:solidFill>
-            </a:endParaRPr>
+          </a:p>
+          <a:p>
+            <a:pPr marL="0" lvl="0" indent="0" algn="l" rtl="0">
+              <a:spcBef>
+                <a:spcPts val="0"/>
+              </a:spcBef>
+              <a:spcAft>
+                <a:spcPts val="0"/>
+              </a:spcAft>
+              <a:buNone/>
+            </a:pPr>
+            <a:endParaRPr lang="en" dirty="0"/>
+          </a:p>
+          <a:p>
+            <a:pPr marL="0" lvl="0" indent="0" algn="l" rtl="0">
+              <a:spcBef>
+                <a:spcPts val="0"/>
+              </a:spcBef>
+              <a:spcAft>
+                <a:spcPts val="0"/>
+              </a:spcAft>
+              <a:buNone/>
+            </a:pPr>
+            <a:r>
+              <a:rPr lang="en-GB" dirty="0"/>
+              <a:t>T</a:t>
+            </a:r>
+            <a:r>
+              <a:rPr lang="en" dirty="0"/>
+              <a:t>ry:</a:t>
+            </a:r>
+          </a:p>
+          <a:p>
+            <a:pPr marL="0" lvl="0" indent="0" algn="l" rtl="0">
+              <a:spcBef>
+                <a:spcPts val="0"/>
+              </a:spcBef>
+              <a:spcAft>
+                <a:spcPts val="0"/>
+              </a:spcAft>
+              <a:buNone/>
+            </a:pPr>
+            <a:endParaRPr lang="en" dirty="0"/>
+          </a:p>
+          <a:p>
+            <a:pPr marL="0" lvl="0" indent="0" algn="l" rtl="0">
+              <a:spcBef>
+                <a:spcPts val="0"/>
+              </a:spcBef>
+              <a:spcAft>
+                <a:spcPts val="0"/>
+              </a:spcAft>
+              <a:buNone/>
+            </a:pPr>
+            <a:r>
+              <a:rPr lang="en-GB" dirty="0"/>
+              <a:t>E</a:t>
+            </a:r>
+            <a:r>
+              <a:rPr lang="en" dirty="0"/>
+              <a:t>xcept ValueError:</a:t>
+            </a:r>
+            <a:endParaRPr dirty="0"/>
           </a:p>
         </p:txBody>
       </p:sp>
@@ -9481,7 +9803,7 @@
   <p:cSld>
     <p:spTree>
       <p:nvGrpSpPr>
-        <p:cNvPr id="1" name="Shape 565"/>
+        <p:cNvPr id="1" name="Shape 575"/>
         <p:cNvGrpSpPr/>
         <p:nvPr/>
       </p:nvGrpSpPr>
@@ -9495,7 +9817,7 @@
       </p:grpSpPr>
       <p:sp>
         <p:nvSpPr>
-          <p:cNvPr id="566" name="Google Shape;566;g14119545db0_0_499:notes"/>
+          <p:cNvPr id="576" name="Google Shape;576;g449b298dd1_21_22:notes"/>
           <p:cNvSpPr>
             <a:spLocks noGrp="1" noRot="1" noChangeAspect="1"/>
           </p:cNvSpPr>
@@ -9536,7 +9858,7 @@
       </p:sp>
       <p:sp>
         <p:nvSpPr>
-          <p:cNvPr id="567" name="Google Shape;567;g14119545db0_0_499:notes"/>
+          <p:cNvPr id="577" name="Google Shape;577;g449b298dd1_21_22:notes"/>
           <p:cNvSpPr txBox="1">
             <a:spLocks noGrp="1"/>
           </p:cNvSpPr>
@@ -9570,7 +9892,7 @@
             </a:pPr>
             <a:r>
               <a:rPr lang="en"/>
-              <a:t>not an issue</a:t>
+              <a:t>mario{0,1}.py</a:t>
             </a:r>
             <a:endParaRPr/>
           </a:p>
@@ -9693,7 +10015,7 @@
   <p:cSld>
     <p:spTree>
       <p:nvGrpSpPr>
-        <p:cNvPr id="1" name="Shape 570"/>
+        <p:cNvPr id="1" name="Shape 580"/>
         <p:cNvGrpSpPr/>
         <p:nvPr/>
       </p:nvGrpSpPr>
@@ -9707,7 +10029,7 @@
       </p:grpSpPr>
       <p:sp>
         <p:nvSpPr>
-          <p:cNvPr id="571" name="Google Shape;571;g2922c153d14_0_214:notes"/>
+          <p:cNvPr id="581" name="Google Shape;581;g449b298dd1_21_13:notes"/>
           <p:cNvSpPr>
             <a:spLocks noGrp="1" noRot="1" noChangeAspect="1"/>
           </p:cNvSpPr>
@@ -9748,7 +10070,7 @@
       </p:sp>
       <p:sp>
         <p:nvSpPr>
-          <p:cNvPr id="572" name="Google Shape;572;g2922c153d14_0_214:notes"/>
+          <p:cNvPr id="582" name="Google Shape;582;g449b298dd1_21_13:notes"/>
           <p:cNvSpPr txBox="1">
             <a:spLocks noGrp="1"/>
           </p:cNvSpPr>
@@ -9782,7 +10104,7 @@
             </a:pPr>
             <a:r>
               <a:rPr lang="en"/>
-              <a:t>integer{0,1,2,3,4}.py</a:t>
+              <a:t>mario{2,3}.py</a:t>
             </a:r>
             <a:endParaRPr/>
           </a:p>
@@ -9801,7 +10123,7 @@
   <p:cSld>
     <p:spTree>
       <p:nvGrpSpPr>
-        <p:cNvPr id="1" name="Shape 575"/>
+        <p:cNvPr id="1" name="Shape 585"/>
         <p:cNvGrpSpPr/>
         <p:nvPr/>
       </p:nvGrpSpPr>
@@ -9815,7 +10137,7 @@
       </p:grpSpPr>
       <p:sp>
         <p:nvSpPr>
-          <p:cNvPr id="576" name="Google Shape;576;g449b298dd1_21_22:notes"/>
+          <p:cNvPr id="586" name="Google Shape;586;g449b298dd1_21_27:notes"/>
           <p:cNvSpPr>
             <a:spLocks noGrp="1" noRot="1" noChangeAspect="1"/>
           </p:cNvSpPr>
@@ -9856,7 +10178,7 @@
       </p:sp>
       <p:sp>
         <p:nvSpPr>
-          <p:cNvPr id="577" name="Google Shape;577;g449b298dd1_21_22:notes"/>
+          <p:cNvPr id="587" name="Google Shape;587;g449b298dd1_21_27:notes"/>
           <p:cNvSpPr txBox="1">
             <a:spLocks noGrp="1"/>
           </p:cNvSpPr>
@@ -9890,7 +10212,7 @@
             </a:pPr>
             <a:r>
               <a:rPr lang="en"/>
-              <a:t>mario{0,1}.py</a:t>
+              <a:t>mario{4,5}.py</a:t>
             </a:r>
             <a:endParaRPr/>
           </a:p>
@@ -9909,7 +10231,7 @@
   <p:cSld>
     <p:spTree>
       <p:nvGrpSpPr>
-        <p:cNvPr id="1" name="Shape 580"/>
+        <p:cNvPr id="1" name="Shape 590"/>
         <p:cNvGrpSpPr/>
         <p:nvPr/>
       </p:nvGrpSpPr>
@@ -9923,7 +10245,7 @@
       </p:grpSpPr>
       <p:sp>
         <p:nvSpPr>
-          <p:cNvPr id="581" name="Google Shape;581;g449b298dd1_21_13:notes"/>
+          <p:cNvPr id="591" name="Google Shape;591;g14119545db0_0_516:notes"/>
           <p:cNvSpPr>
             <a:spLocks noGrp="1" noRot="1" noChangeAspect="1"/>
           </p:cNvSpPr>
@@ -9933,7 +10255,7 @@
         </p:nvSpPr>
         <p:spPr>
           <a:xfrm>
-            <a:off x="381300" y="685800"/>
+            <a:off x="381000" y="685800"/>
             <a:ext cx="6096000" cy="3429000"/>
           </a:xfrm>
           <a:custGeom>
@@ -9964,7 +10286,7 @@
       </p:sp>
       <p:sp>
         <p:nvSpPr>
-          <p:cNvPr id="582" name="Google Shape;582;g449b298dd1_21_13:notes"/>
+          <p:cNvPr id="592" name="Google Shape;592;g14119545db0_0_516:notes"/>
           <p:cNvSpPr txBox="1">
             <a:spLocks noGrp="1"/>
           </p:cNvSpPr>
@@ -9997,10 +10319,10 @@
               <a:buNone/>
             </a:pPr>
             <a:r>
-              <a:rPr lang="en"/>
-              <a:t>mario{2,3}.py</a:t>
+              <a:rPr lang="en-GB" dirty="0"/>
+              <a:t>Automatic linked lists!</a:t>
             </a:r>
-            <a:endParaRPr/>
+            <a:endParaRPr dirty="0"/>
           </a:p>
         </p:txBody>
       </p:sp>
@@ -10017,7 +10339,7 @@
   <p:cSld>
     <p:spTree>
       <p:nvGrpSpPr>
-        <p:cNvPr id="1" name="Shape 585"/>
+        <p:cNvPr id="1" name="Shape 595"/>
         <p:cNvGrpSpPr/>
         <p:nvPr/>
       </p:nvGrpSpPr>
@@ -10031,7 +10353,7 @@
       </p:grpSpPr>
       <p:sp>
         <p:nvSpPr>
-          <p:cNvPr id="586" name="Google Shape;586;g449b298dd1_21_27:notes"/>
+          <p:cNvPr id="596" name="Google Shape;596;g14119545db0_0_534:notes"/>
           <p:cNvSpPr>
             <a:spLocks noGrp="1" noRot="1" noChangeAspect="1"/>
           </p:cNvSpPr>
@@ -10072,7 +10394,7 @@
       </p:sp>
       <p:sp>
         <p:nvSpPr>
-          <p:cNvPr id="587" name="Google Shape;587;g449b298dd1_21_27:notes"/>
+          <p:cNvPr id="597" name="Google Shape;597;g14119545db0_0_534:notes"/>
           <p:cNvSpPr txBox="1">
             <a:spLocks noGrp="1"/>
           </p:cNvSpPr>
@@ -10104,10 +10426,6 @@
               </a:spcAft>
               <a:buNone/>
             </a:pPr>
-            <a:r>
-              <a:rPr lang="en"/>
-              <a:t>mario{4,5}.py</a:t>
-            </a:r>
             <a:endParaRPr/>
           </a:p>
         </p:txBody>
@@ -10125,7 +10443,7 @@
   <p:cSld>
     <p:spTree>
       <p:nvGrpSpPr>
-        <p:cNvPr id="1" name="Shape 590"/>
+        <p:cNvPr id="1" name="Shape 600"/>
         <p:cNvGrpSpPr/>
         <p:nvPr/>
       </p:nvGrpSpPr>
@@ -10139,7 +10457,7 @@
       </p:grpSpPr>
       <p:sp>
         <p:nvSpPr>
-          <p:cNvPr id="591" name="Google Shape;591;g14119545db0_0_516:notes"/>
+          <p:cNvPr id="601" name="Google Shape;601;g14119545db0_0_530:notes"/>
           <p:cNvSpPr>
             <a:spLocks noGrp="1" noRot="1" noChangeAspect="1"/>
           </p:cNvSpPr>
@@ -10180,7 +10498,7 @@
       </p:sp>
       <p:sp>
         <p:nvSpPr>
-          <p:cNvPr id="592" name="Google Shape;592;g14119545db0_0_516:notes"/>
+          <p:cNvPr id="602" name="Google Shape;602;g14119545db0_0_530:notes"/>
           <p:cNvSpPr txBox="1">
             <a:spLocks noGrp="1"/>
           </p:cNvSpPr>
@@ -10229,7 +10547,7 @@
   <p:cSld>
     <p:spTree>
       <p:nvGrpSpPr>
-        <p:cNvPr id="1" name="Shape 595"/>
+        <p:cNvPr id="1" name="Shape 605"/>
         <p:cNvGrpSpPr/>
         <p:nvPr/>
       </p:nvGrpSpPr>
@@ -10243,7 +10561,7 @@
       </p:grpSpPr>
       <p:sp>
         <p:nvSpPr>
-          <p:cNvPr id="596" name="Google Shape;596;g14119545db0_0_534:notes"/>
+          <p:cNvPr id="606" name="Google Shape;606;g14119545db0_0_525:notes"/>
           <p:cNvSpPr>
             <a:spLocks noGrp="1" noRot="1" noChangeAspect="1"/>
           </p:cNvSpPr>
@@ -10284,7 +10602,7 @@
       </p:sp>
       <p:sp>
         <p:nvSpPr>
-          <p:cNvPr id="597" name="Google Shape;597;g14119545db0_0_534:notes"/>
+          <p:cNvPr id="607" name="Google Shape;607;g14119545db0_0_525:notes"/>
           <p:cNvSpPr txBox="1">
             <a:spLocks noGrp="1"/>
           </p:cNvSpPr>
@@ -10316,7 +10634,43 @@
               </a:spcAft>
               <a:buNone/>
             </a:pPr>
-            <a:endParaRPr/>
+            <a:r>
+              <a:rPr lang="en">
+                <a:solidFill>
+                  <a:schemeClr val="dk1"/>
+                </a:solidFill>
+              </a:rPr>
+              <a:t>2/scores{0,1,2}.py</a:t>
+            </a:r>
+            <a:endParaRPr>
+              <a:solidFill>
+                <a:schemeClr val="dk1"/>
+              </a:solidFill>
+            </a:endParaRPr>
+          </a:p>
+          <a:p>
+            <a:pPr marL="0" lvl="0" indent="0" algn="l" rtl="0">
+              <a:spcBef>
+                <a:spcPts val="0"/>
+              </a:spcBef>
+              <a:spcAft>
+                <a:spcPts val="0"/>
+              </a:spcAft>
+              <a:buNone/>
+            </a:pPr>
+            <a:r>
+              <a:rPr lang="en">
+                <a:solidFill>
+                  <a:schemeClr val="dk1"/>
+                </a:solidFill>
+              </a:rPr>
+              <a:t>3/phonebook{0,1}.py</a:t>
+            </a:r>
+            <a:endParaRPr>
+              <a:solidFill>
+                <a:schemeClr val="dk1"/>
+              </a:solidFill>
+            </a:endParaRPr>
           </a:p>
         </p:txBody>
       </p:sp>
@@ -10333,7 +10687,7 @@
   <p:cSld>
     <p:spTree>
       <p:nvGrpSpPr>
-        <p:cNvPr id="1" name="Shape 600"/>
+        <p:cNvPr id="1" name="Shape 610"/>
         <p:cNvGrpSpPr/>
         <p:nvPr/>
       </p:nvGrpSpPr>
@@ -10347,7 +10701,7 @@
       </p:grpSpPr>
       <p:sp>
         <p:nvSpPr>
-          <p:cNvPr id="601" name="Google Shape;601;g14119545db0_0_530:notes"/>
+          <p:cNvPr id="611" name="Google Shape;611;g2922c153d14_0_70:notes"/>
           <p:cNvSpPr>
             <a:spLocks noGrp="1" noRot="1" noChangeAspect="1"/>
           </p:cNvSpPr>
@@ -10388,7 +10742,7 @@
       </p:sp>
       <p:sp>
         <p:nvSpPr>
-          <p:cNvPr id="602" name="Google Shape;602;g14119545db0_0_530:notes"/>
+          <p:cNvPr id="612" name="Google Shape;612;g2922c153d14_0_70:notes"/>
           <p:cNvSpPr txBox="1">
             <a:spLocks noGrp="1"/>
           </p:cNvSpPr>
@@ -10437,7 +10791,7 @@
   <p:cSld>
     <p:spTree>
       <p:nvGrpSpPr>
-        <p:cNvPr id="1" name="Shape 605"/>
+        <p:cNvPr id="1" name="Shape 615"/>
         <p:cNvGrpSpPr/>
         <p:nvPr/>
       </p:nvGrpSpPr>
@@ -10451,7 +10805,7 @@
       </p:grpSpPr>
       <p:sp>
         <p:nvSpPr>
-          <p:cNvPr id="606" name="Google Shape;606;g14119545db0_0_525:notes"/>
+          <p:cNvPr id="616" name="Google Shape;616;g2922c153d14_0_79:notes"/>
           <p:cNvSpPr>
             <a:spLocks noGrp="1" noRot="1" noChangeAspect="1"/>
           </p:cNvSpPr>
@@ -10461,7 +10815,7 @@
         </p:nvSpPr>
         <p:spPr>
           <a:xfrm>
-            <a:off x="381300" y="685800"/>
+            <a:off x="381000" y="685800"/>
             <a:ext cx="6096000" cy="3429000"/>
           </a:xfrm>
           <a:custGeom>
@@ -10492,7 +10846,7 @@
       </p:sp>
       <p:sp>
         <p:nvSpPr>
-          <p:cNvPr id="607" name="Google Shape;607;g14119545db0_0_525:notes"/>
+          <p:cNvPr id="617" name="Google Shape;617;g2922c153d14_0_79:notes"/>
           <p:cNvSpPr txBox="1">
             <a:spLocks noGrp="1"/>
           </p:cNvSpPr>
@@ -10524,43 +10878,7 @@
               </a:spcAft>
               <a:buNone/>
             </a:pPr>
-            <a:r>
-              <a:rPr lang="en">
-                <a:solidFill>
-                  <a:schemeClr val="dk1"/>
-                </a:solidFill>
-              </a:rPr>
-              <a:t>2/scores{0,1,2}.py</a:t>
-            </a:r>
-            <a:endParaRPr>
-              <a:solidFill>
-                <a:schemeClr val="dk1"/>
-              </a:solidFill>
-            </a:endParaRPr>
-          </a:p>
-          <a:p>
-            <a:pPr marL="0" lvl="0" indent="0" algn="l" rtl="0">
-              <a:spcBef>
-                <a:spcPts val="0"/>
-              </a:spcBef>
-              <a:spcAft>
-                <a:spcPts val="0"/>
-              </a:spcAft>
-              <a:buNone/>
-            </a:pPr>
-            <a:r>
-              <a:rPr lang="en">
-                <a:solidFill>
-                  <a:schemeClr val="dk1"/>
-                </a:solidFill>
-              </a:rPr>
-              <a:t>3/phonebook{0,1}.py</a:t>
-            </a:r>
-            <a:endParaRPr>
-              <a:solidFill>
-                <a:schemeClr val="dk1"/>
-              </a:solidFill>
-            </a:endParaRPr>
+            <a:endParaRPr/>
           </a:p>
         </p:txBody>
       </p:sp>
@@ -10577,7 +10895,7 @@
   <p:cSld>
     <p:spTree>
       <p:nvGrpSpPr>
-        <p:cNvPr id="1" name="Shape 610"/>
+        <p:cNvPr id="1" name="Shape 620"/>
         <p:cNvGrpSpPr/>
         <p:nvPr/>
       </p:nvGrpSpPr>
@@ -10591,7 +10909,7 @@
       </p:grpSpPr>
       <p:sp>
         <p:nvSpPr>
-          <p:cNvPr id="611" name="Google Shape;611;g2922c153d14_0_70:notes"/>
+          <p:cNvPr id="621" name="Google Shape;621;g2922c153d14_0_74:notes"/>
           <p:cNvSpPr>
             <a:spLocks noGrp="1" noRot="1" noChangeAspect="1"/>
           </p:cNvSpPr>
@@ -10632,7 +10950,7 @@
       </p:sp>
       <p:sp>
         <p:nvSpPr>
-          <p:cNvPr id="612" name="Google Shape;612;g2922c153d14_0_70:notes"/>
+          <p:cNvPr id="622" name="Google Shape;622;g2922c153d14_0_74:notes"/>
           <p:cNvSpPr txBox="1">
             <a:spLocks noGrp="1"/>
           </p:cNvSpPr>
@@ -10664,6 +10982,10 @@
               </a:spcAft>
               <a:buNone/>
             </a:pPr>
+            <a:r>
+              <a:rPr lang="en"/>
+              <a:t>phonebook{2,3,4}.py</a:t>
+            </a:r>
             <a:endParaRPr/>
           </a:p>
         </p:txBody>
@@ -10681,7 +11003,7 @@
   <p:cSld>
     <p:spTree>
       <p:nvGrpSpPr>
-        <p:cNvPr id="1" name="Shape 615"/>
+        <p:cNvPr id="1" name="Shape 625"/>
         <p:cNvGrpSpPr/>
         <p:nvPr/>
       </p:nvGrpSpPr>
@@ -10695,7 +11017,7 @@
       </p:grpSpPr>
       <p:sp>
         <p:nvSpPr>
-          <p:cNvPr id="616" name="Google Shape;616;g2922c153d14_0_79:notes"/>
+          <p:cNvPr id="626" name="Google Shape;626;g14119545db0_0_539:notes"/>
           <p:cNvSpPr>
             <a:spLocks noGrp="1" noRot="1" noChangeAspect="1"/>
           </p:cNvSpPr>
@@ -10736,7 +11058,7 @@
       </p:sp>
       <p:sp>
         <p:nvSpPr>
-          <p:cNvPr id="617" name="Google Shape;617;g2922c153d14_0_79:notes"/>
+          <p:cNvPr id="627" name="Google Shape;627;g14119545db0_0_539:notes"/>
           <p:cNvSpPr txBox="1">
             <a:spLocks noGrp="1"/>
           </p:cNvSpPr>
@@ -10889,7 +11211,7 @@
   <p:cSld>
     <p:spTree>
       <p:nvGrpSpPr>
-        <p:cNvPr id="1" name="Shape 620"/>
+        <p:cNvPr id="1" name="Shape 630"/>
         <p:cNvGrpSpPr/>
         <p:nvPr/>
       </p:nvGrpSpPr>
@@ -10903,7 +11225,7 @@
       </p:grpSpPr>
       <p:sp>
         <p:nvSpPr>
-          <p:cNvPr id="621" name="Google Shape;621;g2922c153d14_0_74:notes"/>
+          <p:cNvPr id="631" name="Google Shape;631;g14119545db0_0_543:notes"/>
           <p:cNvSpPr>
             <a:spLocks noGrp="1" noRot="1" noChangeAspect="1"/>
           </p:cNvSpPr>
@@ -10944,7 +11266,7 @@
       </p:sp>
       <p:sp>
         <p:nvSpPr>
-          <p:cNvPr id="622" name="Google Shape;622;g2922c153d14_0_74:notes"/>
+          <p:cNvPr id="632" name="Google Shape;632;g14119545db0_0_543:notes"/>
           <p:cNvSpPr txBox="1">
             <a:spLocks noGrp="1"/>
           </p:cNvSpPr>
@@ -10977,10 +11299,42 @@
               <a:buNone/>
             </a:pPr>
             <a:r>
-              <a:rPr lang="en"/>
-              <a:t>phonebook{2,3,4}.py</a:t>
+              <a:rPr lang="en">
+                <a:solidFill>
+                  <a:schemeClr val="dk1"/>
+                </a:solidFill>
+              </a:rPr>
+              <a:t>2/greet{0,1,2}.py</a:t>
             </a:r>
-            <a:endParaRPr/>
+            <a:endParaRPr>
+              <a:solidFill>
+                <a:schemeClr val="dk1"/>
+              </a:solidFill>
+            </a:endParaRPr>
+          </a:p>
+          <a:p>
+            <a:pPr marL="0" lvl="0" indent="0" algn="l" rtl="0">
+              <a:spcBef>
+                <a:spcPts val="0"/>
+              </a:spcBef>
+              <a:spcAft>
+                <a:spcPts val="0"/>
+              </a:spcAft>
+              <a:buNone/>
+            </a:pPr>
+            <a:r>
+              <a:rPr lang="en">
+                <a:solidFill>
+                  <a:schemeClr val="dk1"/>
+                </a:solidFill>
+              </a:rPr>
+              <a:t>2/exit.py</a:t>
+            </a:r>
+            <a:endParaRPr>
+              <a:solidFill>
+                <a:schemeClr val="dk1"/>
+              </a:solidFill>
+            </a:endParaRPr>
           </a:p>
         </p:txBody>
       </p:sp>
@@ -10997,7 +11351,7 @@
   <p:cSld>
     <p:spTree>
       <p:nvGrpSpPr>
-        <p:cNvPr id="1" name="Shape 625"/>
+        <p:cNvPr id="1" name="Shape 635"/>
         <p:cNvGrpSpPr/>
         <p:nvPr/>
       </p:nvGrpSpPr>
@@ -11011,7 +11365,7 @@
       </p:grpSpPr>
       <p:sp>
         <p:nvSpPr>
-          <p:cNvPr id="626" name="Google Shape;626;g14119545db0_0_539:notes"/>
+          <p:cNvPr id="636" name="Google Shape;636;g14119545db0_0_651:notes"/>
           <p:cNvSpPr>
             <a:spLocks noGrp="1" noRot="1" noChangeAspect="1"/>
           </p:cNvSpPr>
@@ -11052,7 +11406,7 @@
       </p:sp>
       <p:sp>
         <p:nvSpPr>
-          <p:cNvPr id="627" name="Google Shape;627;g14119545db0_0_539:notes"/>
+          <p:cNvPr id="637" name="Google Shape;637;g14119545db0_0_651:notes"/>
           <p:cNvSpPr txBox="1">
             <a:spLocks noGrp="1"/>
           </p:cNvSpPr>
@@ -11101,7 +11455,7 @@
   <p:cSld>
     <p:spTree>
       <p:nvGrpSpPr>
-        <p:cNvPr id="1" name="Shape 630"/>
+        <p:cNvPr id="1" name="Shape 640"/>
         <p:cNvGrpSpPr/>
         <p:nvPr/>
       </p:nvGrpSpPr>
@@ -11115,7 +11469,7 @@
       </p:grpSpPr>
       <p:sp>
         <p:nvSpPr>
-          <p:cNvPr id="631" name="Google Shape;631;g14119545db0_0_543:notes"/>
+          <p:cNvPr id="641" name="Google Shape;641;g14119545db0_0_655:notes"/>
           <p:cNvSpPr>
             <a:spLocks noGrp="1" noRot="1" noChangeAspect="1"/>
           </p:cNvSpPr>
@@ -11156,7 +11510,7 @@
       </p:sp>
       <p:sp>
         <p:nvSpPr>
-          <p:cNvPr id="632" name="Google Shape;632;g14119545db0_0_543:notes"/>
+          <p:cNvPr id="642" name="Google Shape;642;g14119545db0_0_655:notes"/>
           <p:cNvSpPr txBox="1">
             <a:spLocks noGrp="1"/>
           </p:cNvSpPr>
@@ -11189,42 +11543,10 @@
               <a:buNone/>
             </a:pPr>
             <a:r>
-              <a:rPr lang="en">
-                <a:solidFill>
-                  <a:schemeClr val="dk1"/>
-                </a:solidFill>
-              </a:rPr>
-              <a:t>2/greet{0,1,2}.py</a:t>
+              <a:rPr lang="en"/>
+              <a:t>4/phonebook{0,1,2}.py</a:t>
             </a:r>
-            <a:endParaRPr>
-              <a:solidFill>
-                <a:schemeClr val="dk1"/>
-              </a:solidFill>
-            </a:endParaRPr>
-          </a:p>
-          <a:p>
-            <a:pPr marL="0" lvl="0" indent="0" algn="l" rtl="0">
-              <a:spcBef>
-                <a:spcPts val="0"/>
-              </a:spcBef>
-              <a:spcAft>
-                <a:spcPts val="0"/>
-              </a:spcAft>
-              <a:buNone/>
-            </a:pPr>
-            <a:r>
-              <a:rPr lang="en">
-                <a:solidFill>
-                  <a:schemeClr val="dk1"/>
-                </a:solidFill>
-              </a:rPr>
-              <a:t>2/exit.py</a:t>
-            </a:r>
-            <a:endParaRPr>
-              <a:solidFill>
-                <a:schemeClr val="dk1"/>
-              </a:solidFill>
-            </a:endParaRPr>
+            <a:endParaRPr/>
           </a:p>
         </p:txBody>
       </p:sp>
@@ -11241,7 +11563,7 @@
   <p:cSld>
     <p:spTree>
       <p:nvGrpSpPr>
-        <p:cNvPr id="1" name="Shape 635"/>
+        <p:cNvPr id="1" name="Shape 645"/>
         <p:cNvGrpSpPr/>
         <p:nvPr/>
       </p:nvGrpSpPr>
@@ -11255,7 +11577,7 @@
       </p:grpSpPr>
       <p:sp>
         <p:nvSpPr>
-          <p:cNvPr id="636" name="Google Shape;636;g14119545db0_0_651:notes"/>
+          <p:cNvPr id="646" name="Google Shape;646;g2922c153d14_0_270:notes"/>
           <p:cNvSpPr>
             <a:spLocks noGrp="1" noRot="1" noChangeAspect="1"/>
           </p:cNvSpPr>
@@ -11296,7 +11618,7 @@
       </p:sp>
       <p:sp>
         <p:nvSpPr>
-          <p:cNvPr id="637" name="Google Shape;637;g14119545db0_0_651:notes"/>
+          <p:cNvPr id="647" name="Google Shape;647;g2922c153d14_0_270:notes"/>
           <p:cNvSpPr txBox="1">
             <a:spLocks noGrp="1"/>
           </p:cNvSpPr>
@@ -11328,6 +11650,58 @@
               </a:spcAft>
               <a:buNone/>
             </a:pPr>
+            <a:r>
+              <a:rPr lang="en"/>
+              <a:t>pip install cowsay</a:t>
+            </a:r>
+            <a:endParaRPr/>
+          </a:p>
+          <a:p>
+            <a:pPr marL="0" lvl="0" indent="0" algn="l" rtl="0">
+              <a:spcBef>
+                <a:spcPts val="0"/>
+              </a:spcBef>
+              <a:spcAft>
+                <a:spcPts val="0"/>
+              </a:spcAft>
+              <a:buNone/>
+            </a:pPr>
+            <a:r>
+              <a:rPr lang="en"/>
+              <a:t>moo{0,1}.py</a:t>
+            </a:r>
+            <a:endParaRPr/>
+          </a:p>
+          <a:p>
+            <a:pPr marL="0" lvl="0" indent="0" algn="l" rtl="0">
+              <a:spcBef>
+                <a:spcPts val="0"/>
+              </a:spcBef>
+              <a:spcAft>
+                <a:spcPts val="0"/>
+              </a:spcAft>
+              <a:buNone/>
+            </a:pPr>
+            <a:r>
+              <a:rPr lang="en"/>
+              <a:t>pip install qrcode</a:t>
+            </a:r>
+            <a:endParaRPr/>
+          </a:p>
+          <a:p>
+            <a:pPr marL="0" lvl="0" indent="0" algn="l" rtl="0">
+              <a:spcBef>
+                <a:spcPts val="0"/>
+              </a:spcBef>
+              <a:spcAft>
+                <a:spcPts val="0"/>
+              </a:spcAft>
+              <a:buNone/>
+            </a:pPr>
+            <a:r>
+              <a:rPr lang="en"/>
+              <a:t>qr.py</a:t>
+            </a:r>
             <a:endParaRPr/>
           </a:p>
         </p:txBody>
@@ -11341,270 +11715,6 @@
 </file>
 
 <file path=ppt/notesSlides/notesSlide94.xml><?xml version="1.0" encoding="utf-8"?>
-<p:notes xmlns:a="http://schemas.openxmlformats.org/drawingml/2006/main" xmlns:r="http://schemas.openxmlformats.org/officeDocument/2006/relationships" xmlns:p="http://schemas.openxmlformats.org/presentationml/2006/main" showMasterSp="0" showMasterPhAnim="0">
-  <p:cSld>
-    <p:spTree>
-      <p:nvGrpSpPr>
-        <p:cNvPr id="1" name="Shape 640"/>
-        <p:cNvGrpSpPr/>
-        <p:nvPr/>
-      </p:nvGrpSpPr>
-      <p:grpSpPr>
-        <a:xfrm>
-          <a:off x="0" y="0"/>
-          <a:ext cx="0" cy="0"/>
-          <a:chOff x="0" y="0"/>
-          <a:chExt cx="0" cy="0"/>
-        </a:xfrm>
-      </p:grpSpPr>
-      <p:sp>
-        <p:nvSpPr>
-          <p:cNvPr id="641" name="Google Shape;641;g14119545db0_0_655:notes"/>
-          <p:cNvSpPr>
-            <a:spLocks noGrp="1" noRot="1" noChangeAspect="1"/>
-          </p:cNvSpPr>
-          <p:nvPr>
-            <p:ph type="sldImg" idx="2"/>
-          </p:nvPr>
-        </p:nvSpPr>
-        <p:spPr>
-          <a:xfrm>
-            <a:off x="381300" y="685800"/>
-            <a:ext cx="6096000" cy="3429000"/>
-          </a:xfrm>
-          <a:custGeom>
-            <a:avLst/>
-            <a:gdLst/>
-            <a:ahLst/>
-            <a:cxnLst/>
-            <a:rect l="l" t="t" r="r" b="b"/>
-            <a:pathLst>
-              <a:path w="120000" h="120000" extrusionOk="0">
-                <a:moveTo>
-                  <a:pt x="0" y="0"/>
-                </a:moveTo>
-                <a:lnTo>
-                  <a:pt x="120000" y="0"/>
-                </a:lnTo>
-                <a:lnTo>
-                  <a:pt x="120000" y="120000"/>
-                </a:lnTo>
-                <a:lnTo>
-                  <a:pt x="0" y="120000"/>
-                </a:lnTo>
-                <a:close/>
-              </a:path>
-            </a:pathLst>
-          </a:custGeom>
-        </p:spPr>
-      </p:sp>
-      <p:sp>
-        <p:nvSpPr>
-          <p:cNvPr id="642" name="Google Shape;642;g14119545db0_0_655:notes"/>
-          <p:cNvSpPr txBox="1">
-            <a:spLocks noGrp="1"/>
-          </p:cNvSpPr>
-          <p:nvPr>
-            <p:ph type="body" idx="1"/>
-          </p:nvPr>
-        </p:nvSpPr>
-        <p:spPr>
-          <a:xfrm>
-            <a:off x="685800" y="4343400"/>
-            <a:ext cx="5486400" cy="4114800"/>
-          </a:xfrm>
-          <a:prstGeom prst="rect">
-            <a:avLst/>
-          </a:prstGeom>
-        </p:spPr>
-        <p:txBody>
-          <a:bodyPr spcFirstLastPara="1" wrap="square" lIns="91425" tIns="91425" rIns="91425" bIns="91425" anchor="t" anchorCtr="0">
-            <a:noAutofit/>
-          </a:bodyPr>
-          <a:lstStyle/>
-          <a:p>
-            <a:pPr marL="0" lvl="0" indent="0" algn="l" rtl="0">
-              <a:spcBef>
-                <a:spcPts val="0"/>
-              </a:spcBef>
-              <a:spcAft>
-                <a:spcPts val="0"/>
-              </a:spcAft>
-              <a:buNone/>
-            </a:pPr>
-            <a:r>
-              <a:rPr lang="en"/>
-              <a:t>4/phonebook{0,1,2}.py</a:t>
-            </a:r>
-            <a:endParaRPr/>
-          </a:p>
-        </p:txBody>
-      </p:sp>
-    </p:spTree>
-  </p:cSld>
-  <p:clrMapOvr>
-    <a:masterClrMapping/>
-  </p:clrMapOvr>
-</p:notes>
-</file>
-
-<file path=ppt/notesSlides/notesSlide95.xml><?xml version="1.0" encoding="utf-8"?>
-<p:notes xmlns:a="http://schemas.openxmlformats.org/drawingml/2006/main" xmlns:r="http://schemas.openxmlformats.org/officeDocument/2006/relationships" xmlns:p="http://schemas.openxmlformats.org/presentationml/2006/main" showMasterSp="0" showMasterPhAnim="0">
-  <p:cSld>
-    <p:spTree>
-      <p:nvGrpSpPr>
-        <p:cNvPr id="1" name="Shape 645"/>
-        <p:cNvGrpSpPr/>
-        <p:nvPr/>
-      </p:nvGrpSpPr>
-      <p:grpSpPr>
-        <a:xfrm>
-          <a:off x="0" y="0"/>
-          <a:ext cx="0" cy="0"/>
-          <a:chOff x="0" y="0"/>
-          <a:chExt cx="0" cy="0"/>
-        </a:xfrm>
-      </p:grpSpPr>
-      <p:sp>
-        <p:nvSpPr>
-          <p:cNvPr id="646" name="Google Shape;646;g2922c153d14_0_270:notes"/>
-          <p:cNvSpPr>
-            <a:spLocks noGrp="1" noRot="1" noChangeAspect="1"/>
-          </p:cNvSpPr>
-          <p:nvPr>
-            <p:ph type="sldImg" idx="2"/>
-          </p:nvPr>
-        </p:nvSpPr>
-        <p:spPr>
-          <a:xfrm>
-            <a:off x="381300" y="685800"/>
-            <a:ext cx="6096000" cy="3429000"/>
-          </a:xfrm>
-          <a:custGeom>
-            <a:avLst/>
-            <a:gdLst/>
-            <a:ahLst/>
-            <a:cxnLst/>
-            <a:rect l="l" t="t" r="r" b="b"/>
-            <a:pathLst>
-              <a:path w="120000" h="120000" extrusionOk="0">
-                <a:moveTo>
-                  <a:pt x="0" y="0"/>
-                </a:moveTo>
-                <a:lnTo>
-                  <a:pt x="120000" y="0"/>
-                </a:lnTo>
-                <a:lnTo>
-                  <a:pt x="120000" y="120000"/>
-                </a:lnTo>
-                <a:lnTo>
-                  <a:pt x="0" y="120000"/>
-                </a:lnTo>
-                <a:close/>
-              </a:path>
-            </a:pathLst>
-          </a:custGeom>
-        </p:spPr>
-      </p:sp>
-      <p:sp>
-        <p:nvSpPr>
-          <p:cNvPr id="647" name="Google Shape;647;g2922c153d14_0_270:notes"/>
-          <p:cNvSpPr txBox="1">
-            <a:spLocks noGrp="1"/>
-          </p:cNvSpPr>
-          <p:nvPr>
-            <p:ph type="body" idx="1"/>
-          </p:nvPr>
-        </p:nvSpPr>
-        <p:spPr>
-          <a:xfrm>
-            <a:off x="685800" y="4343400"/>
-            <a:ext cx="5486400" cy="4114800"/>
-          </a:xfrm>
-          <a:prstGeom prst="rect">
-            <a:avLst/>
-          </a:prstGeom>
-        </p:spPr>
-        <p:txBody>
-          <a:bodyPr spcFirstLastPara="1" wrap="square" lIns="91425" tIns="91425" rIns="91425" bIns="91425" anchor="t" anchorCtr="0">
-            <a:noAutofit/>
-          </a:bodyPr>
-          <a:lstStyle/>
-          <a:p>
-            <a:pPr marL="0" lvl="0" indent="0" algn="l" rtl="0">
-              <a:spcBef>
-                <a:spcPts val="0"/>
-              </a:spcBef>
-              <a:spcAft>
-                <a:spcPts val="0"/>
-              </a:spcAft>
-              <a:buNone/>
-            </a:pPr>
-            <a:r>
-              <a:rPr lang="en"/>
-              <a:t>pip install cowsay</a:t>
-            </a:r>
-            <a:endParaRPr/>
-          </a:p>
-          <a:p>
-            <a:pPr marL="0" lvl="0" indent="0" algn="l" rtl="0">
-              <a:spcBef>
-                <a:spcPts val="0"/>
-              </a:spcBef>
-              <a:spcAft>
-                <a:spcPts val="0"/>
-              </a:spcAft>
-              <a:buNone/>
-            </a:pPr>
-            <a:r>
-              <a:rPr lang="en"/>
-              <a:t>moo{0,1}.py</a:t>
-            </a:r>
-            <a:endParaRPr/>
-          </a:p>
-          <a:p>
-            <a:pPr marL="0" lvl="0" indent="0" algn="l" rtl="0">
-              <a:spcBef>
-                <a:spcPts val="0"/>
-              </a:spcBef>
-              <a:spcAft>
-                <a:spcPts val="0"/>
-              </a:spcAft>
-              <a:buNone/>
-            </a:pPr>
-            <a:r>
-              <a:rPr lang="en"/>
-              <a:t>pip install qrcode</a:t>
-            </a:r>
-            <a:endParaRPr/>
-          </a:p>
-          <a:p>
-            <a:pPr marL="0" lvl="0" indent="0" algn="l" rtl="0">
-              <a:spcBef>
-                <a:spcPts val="0"/>
-              </a:spcBef>
-              <a:spcAft>
-                <a:spcPts val="0"/>
-              </a:spcAft>
-              <a:buNone/>
-            </a:pPr>
-            <a:r>
-              <a:rPr lang="en"/>
-              <a:t>qr.py</a:t>
-            </a:r>
-            <a:endParaRPr/>
-          </a:p>
-        </p:txBody>
-      </p:sp>
-    </p:spTree>
-  </p:cSld>
-  <p:clrMapOvr>
-    <a:masterClrMapping/>
-  </p:clrMapOvr>
-</p:notes>
-</file>
-
-<file path=ppt/notesSlides/notesSlide96.xml><?xml version="1.0" encoding="utf-8"?>
 <p:notes xmlns:a="http://schemas.openxmlformats.org/drawingml/2006/main" xmlns:r="http://schemas.openxmlformats.org/officeDocument/2006/relationships" xmlns:p="http://schemas.openxmlformats.org/presentationml/2006/main" showMasterSp="0" showMasterPhAnim="0">
   <p:cSld>
     <p:spTree>
@@ -29677,59 +29787,6 @@
 <file path=ppt/slides/slide73.xml><?xml version="1.0" encoding="utf-8"?>
 <p:sld xmlns:a="http://schemas.openxmlformats.org/drawingml/2006/main" xmlns:r="http://schemas.openxmlformats.org/officeDocument/2006/relationships" xmlns:p="http://schemas.openxmlformats.org/presentationml/2006/main">
   <p:cSld>
-    <p:spTree>
-      <p:nvGrpSpPr>
-        <p:cNvPr id="1" name="Shape 529"/>
-        <p:cNvGrpSpPr/>
-        <p:nvPr/>
-      </p:nvGrpSpPr>
-      <p:grpSpPr>
-        <a:xfrm>
-          <a:off x="0" y="0"/>
-          <a:ext cx="0" cy="0"/>
-          <a:chOff x="0" y="0"/>
-          <a:chExt cx="0" cy="0"/>
-        </a:xfrm>
-      </p:grpSpPr>
-      <p:pic>
-        <p:nvPicPr>
-          <p:cNvPr id="530" name="Google Shape;530;p88"/>
-          <p:cNvPicPr preferRelativeResize="0"/>
-          <p:nvPr/>
-        </p:nvPicPr>
-        <p:blipFill>
-          <a:blip r:embed="rId3">
-            <a:alphaModFix/>
-          </a:blip>
-          <a:stretch>
-            <a:fillRect/>
-          </a:stretch>
-        </p:blipFill>
-        <p:spPr>
-          <a:xfrm>
-            <a:off x="2559988" y="152400"/>
-            <a:ext cx="4024023" cy="4838702"/>
-          </a:xfrm>
-          <a:prstGeom prst="rect">
-            <a:avLst/>
-          </a:prstGeom>
-          <a:noFill/>
-          <a:ln>
-            <a:noFill/>
-          </a:ln>
-        </p:spPr>
-      </p:pic>
-    </p:spTree>
-  </p:cSld>
-  <p:clrMapOvr>
-    <a:masterClrMapping/>
-  </p:clrMapOvr>
-</p:sld>
-</file>
-
-<file path=ppt/slides/slide74.xml><?xml version="1.0" encoding="utf-8"?>
-<p:sld xmlns:a="http://schemas.openxmlformats.org/drawingml/2006/main" xmlns:r="http://schemas.openxmlformats.org/officeDocument/2006/relationships" xmlns:p="http://schemas.openxmlformats.org/presentationml/2006/main">
-  <p:cSld>
     <p:bg>
       <p:bgPr>
         <a:solidFill>
@@ -29998,7 +30055,7 @@
 </p:sld>
 </file>
 
-<file path=ppt/slides/slide75.xml><?xml version="1.0" encoding="utf-8"?>
+<file path=ppt/slides/slide74.xml><?xml version="1.0" encoding="utf-8"?>
 <p:sld xmlns:a="http://schemas.openxmlformats.org/drawingml/2006/main" xmlns:r="http://schemas.openxmlformats.org/officeDocument/2006/relationships" xmlns:p="http://schemas.openxmlformats.org/presentationml/2006/main">
   <p:cSld>
     <p:bg>
@@ -30293,7 +30350,7 @@
 </p:sld>
 </file>
 
-<file path=ppt/slides/slide76.xml><?xml version="1.0" encoding="utf-8"?>
+<file path=ppt/slides/slide75.xml><?xml version="1.0" encoding="utf-8"?>
 <p:sld xmlns:a="http://schemas.openxmlformats.org/drawingml/2006/main" xmlns:r="http://schemas.openxmlformats.org/officeDocument/2006/relationships" xmlns:p="http://schemas.openxmlformats.org/presentationml/2006/main">
   <p:cSld>
     <p:bg>
@@ -30524,7 +30581,7 @@
 </p:sld>
 </file>
 
-<file path=ppt/slides/slide77.xml><?xml version="1.0" encoding="utf-8"?>
+<file path=ppt/slides/slide76.xml><?xml version="1.0" encoding="utf-8"?>
 <p:sld xmlns:a="http://schemas.openxmlformats.org/drawingml/2006/main" xmlns:r="http://schemas.openxmlformats.org/officeDocument/2006/relationships" xmlns:p="http://schemas.openxmlformats.org/presentationml/2006/main">
   <p:cSld>
     <p:spTree>
@@ -30591,7 +30648,7 @@
 </p:sld>
 </file>
 
-<file path=ppt/slides/slide78.xml><?xml version="1.0" encoding="utf-8"?>
+<file path=ppt/slides/slide77.xml><?xml version="1.0" encoding="utf-8"?>
 <p:sld xmlns:a="http://schemas.openxmlformats.org/drawingml/2006/main" xmlns:r="http://schemas.openxmlformats.org/officeDocument/2006/relationships" xmlns:p="http://schemas.openxmlformats.org/presentationml/2006/main">
   <p:cSld>
     <p:spTree>
@@ -30658,141 +30715,7 @@
 </p:sld>
 </file>
 
-<file path=ppt/slides/slide79.xml><?xml version="1.0" encoding="utf-8"?>
-<p:sld xmlns:a="http://schemas.openxmlformats.org/drawingml/2006/main" xmlns:r="http://schemas.openxmlformats.org/officeDocument/2006/relationships" xmlns:p="http://schemas.openxmlformats.org/presentationml/2006/main">
-  <p:cSld>
-    <p:spTree>
-      <p:nvGrpSpPr>
-        <p:cNvPr id="1" name="Shape 568"/>
-        <p:cNvGrpSpPr/>
-        <p:nvPr/>
-      </p:nvGrpSpPr>
-      <p:grpSpPr>
-        <a:xfrm>
-          <a:off x="0" y="0"/>
-          <a:ext cx="0" cy="0"/>
-          <a:chOff x="0" y="0"/>
-          <a:chExt cx="0" cy="0"/>
-        </a:xfrm>
-      </p:grpSpPr>
-      <p:sp>
-        <p:nvSpPr>
-          <p:cNvPr id="569" name="Google Shape;569;p94"/>
-          <p:cNvSpPr txBox="1">
-            <a:spLocks noGrp="1"/>
-          </p:cNvSpPr>
-          <p:nvPr>
-            <p:ph type="title"/>
-          </p:nvPr>
-        </p:nvSpPr>
-        <p:spPr>
-          <a:xfrm>
-            <a:off x="311700" y="2150850"/>
-            <a:ext cx="8520600" cy="841800"/>
-          </a:xfrm>
-          <a:prstGeom prst="rect">
-            <a:avLst/>
-          </a:prstGeom>
-        </p:spPr>
-        <p:txBody>
-          <a:bodyPr spcFirstLastPara="1" wrap="square" lIns="91425" tIns="91425" rIns="91425" bIns="91425" anchor="ctr" anchorCtr="0">
-            <a:noAutofit/>
-          </a:bodyPr>
-          <a:lstStyle/>
-          <a:p>
-            <a:pPr marL="0" lvl="0" indent="0" algn="ctr" rtl="0">
-              <a:spcBef>
-                <a:spcPts val="0"/>
-              </a:spcBef>
-              <a:spcAft>
-                <a:spcPts val="0"/>
-              </a:spcAft>
-              <a:buNone/>
-            </a:pPr>
-            <a:r>
-              <a:rPr lang="en"/>
-              <a:t>integer overflow</a:t>
-            </a:r>
-            <a:endParaRPr/>
-          </a:p>
-        </p:txBody>
-      </p:sp>
-    </p:spTree>
-  </p:cSld>
-  <p:clrMapOvr>
-    <a:masterClrMapping/>
-  </p:clrMapOvr>
-</p:sld>
-</file>
-
-<file path=ppt/slides/slide8.xml><?xml version="1.0" encoding="utf-8"?>
-<p:sld xmlns:a="http://schemas.openxmlformats.org/drawingml/2006/main" xmlns:r="http://schemas.openxmlformats.org/officeDocument/2006/relationships" xmlns:p="http://schemas.openxmlformats.org/presentationml/2006/main">
-  <p:cSld>
-    <p:spTree>
-      <p:nvGrpSpPr>
-        <p:cNvPr id="1" name="Shape 99"/>
-        <p:cNvGrpSpPr/>
-        <p:nvPr/>
-      </p:nvGrpSpPr>
-      <p:grpSpPr>
-        <a:xfrm>
-          <a:off x="0" y="0"/>
-          <a:ext cx="0" cy="0"/>
-          <a:chOff x="0" y="0"/>
-          <a:chExt cx="0" cy="0"/>
-        </a:xfrm>
-      </p:grpSpPr>
-      <p:sp>
-        <p:nvSpPr>
-          <p:cNvPr id="100" name="Google Shape;100;p22"/>
-          <p:cNvSpPr txBox="1">
-            <a:spLocks noGrp="1"/>
-          </p:cNvSpPr>
-          <p:nvPr>
-            <p:ph type="title"/>
-          </p:nvPr>
-        </p:nvSpPr>
-        <p:spPr>
-          <a:xfrm>
-            <a:off x="311700" y="2150850"/>
-            <a:ext cx="8520600" cy="841800"/>
-          </a:xfrm>
-          <a:prstGeom prst="rect">
-            <a:avLst/>
-          </a:prstGeom>
-        </p:spPr>
-        <p:txBody>
-          <a:bodyPr spcFirstLastPara="1" wrap="square" lIns="91425" tIns="91425" rIns="91425" bIns="91425" anchor="ctr" anchorCtr="0">
-            <a:noAutofit/>
-          </a:bodyPr>
-          <a:lstStyle/>
-          <a:p>
-            <a:pPr marL="0" lvl="0" indent="0" algn="ctr" rtl="0">
-              <a:spcBef>
-                <a:spcPts val="0"/>
-              </a:spcBef>
-              <a:spcAft>
-                <a:spcPts val="0"/>
-              </a:spcAft>
-              <a:buNone/>
-            </a:pPr>
-            <a:r>
-              <a:rPr lang="en"/>
-              <a:t>compiled, interpreted</a:t>
-            </a:r>
-            <a:endParaRPr/>
-          </a:p>
-        </p:txBody>
-      </p:sp>
-    </p:spTree>
-  </p:cSld>
-  <p:clrMapOvr>
-    <a:masterClrMapping/>
-  </p:clrMapOvr>
-</p:sld>
-</file>
-
-<file path=ppt/slides/slide80.xml><?xml version="1.0" encoding="utf-8"?>
+<file path=ppt/slides/slide78.xml><?xml version="1.0" encoding="utf-8"?>
 <p:sld xmlns:a="http://schemas.openxmlformats.org/drawingml/2006/main" xmlns:r="http://schemas.openxmlformats.org/officeDocument/2006/relationships" xmlns:p="http://schemas.openxmlformats.org/presentationml/2006/main">
   <p:cSld>
     <p:spTree>
@@ -30859,7 +30782,7 @@
 </p:sld>
 </file>
 
-<file path=ppt/slides/slide81.xml><?xml version="1.0" encoding="utf-8"?>
+<file path=ppt/slides/slide79.xml><?xml version="1.0" encoding="utf-8"?>
 <p:sld xmlns:a="http://schemas.openxmlformats.org/drawingml/2006/main" xmlns:r="http://schemas.openxmlformats.org/officeDocument/2006/relationships" xmlns:p="http://schemas.openxmlformats.org/presentationml/2006/main">
   <p:cSld>
     <p:spTree>
@@ -30912,7 +30835,74 @@
 </p:sld>
 </file>
 
-<file path=ppt/slides/slide82.xml><?xml version="1.0" encoding="utf-8"?>
+<file path=ppt/slides/slide8.xml><?xml version="1.0" encoding="utf-8"?>
+<p:sld xmlns:a="http://schemas.openxmlformats.org/drawingml/2006/main" xmlns:r="http://schemas.openxmlformats.org/officeDocument/2006/relationships" xmlns:p="http://schemas.openxmlformats.org/presentationml/2006/main">
+  <p:cSld>
+    <p:spTree>
+      <p:nvGrpSpPr>
+        <p:cNvPr id="1" name="Shape 99"/>
+        <p:cNvGrpSpPr/>
+        <p:nvPr/>
+      </p:nvGrpSpPr>
+      <p:grpSpPr>
+        <a:xfrm>
+          <a:off x="0" y="0"/>
+          <a:ext cx="0" cy="0"/>
+          <a:chOff x="0" y="0"/>
+          <a:chExt cx="0" cy="0"/>
+        </a:xfrm>
+      </p:grpSpPr>
+      <p:sp>
+        <p:nvSpPr>
+          <p:cNvPr id="100" name="Google Shape;100;p22"/>
+          <p:cNvSpPr txBox="1">
+            <a:spLocks noGrp="1"/>
+          </p:cNvSpPr>
+          <p:nvPr>
+            <p:ph type="title"/>
+          </p:nvPr>
+        </p:nvSpPr>
+        <p:spPr>
+          <a:xfrm>
+            <a:off x="311700" y="2150850"/>
+            <a:ext cx="8520600" cy="841800"/>
+          </a:xfrm>
+          <a:prstGeom prst="rect">
+            <a:avLst/>
+          </a:prstGeom>
+        </p:spPr>
+        <p:txBody>
+          <a:bodyPr spcFirstLastPara="1" wrap="square" lIns="91425" tIns="91425" rIns="91425" bIns="91425" anchor="ctr" anchorCtr="0">
+            <a:noAutofit/>
+          </a:bodyPr>
+          <a:lstStyle/>
+          <a:p>
+            <a:pPr marL="0" lvl="0" indent="0" algn="ctr" rtl="0">
+              <a:spcBef>
+                <a:spcPts val="0"/>
+              </a:spcBef>
+              <a:spcAft>
+                <a:spcPts val="0"/>
+              </a:spcAft>
+              <a:buNone/>
+            </a:pPr>
+            <a:r>
+              <a:rPr lang="en"/>
+              <a:t>compiled, interpreted</a:t>
+            </a:r>
+            <a:endParaRPr/>
+          </a:p>
+        </p:txBody>
+      </p:sp>
+    </p:spTree>
+  </p:cSld>
+  <p:clrMapOvr>
+    <a:masterClrMapping/>
+  </p:clrMapOvr>
+</p:sld>
+</file>
+
+<file path=ppt/slides/slide80.xml><?xml version="1.0" encoding="utf-8"?>
 <p:sld xmlns:a="http://schemas.openxmlformats.org/drawingml/2006/main" xmlns:r="http://schemas.openxmlformats.org/officeDocument/2006/relationships" xmlns:p="http://schemas.openxmlformats.org/presentationml/2006/main">
   <p:cSld>
     <p:spTree>
@@ -30965,7 +30955,7 @@
 </p:sld>
 </file>
 
-<file path=ppt/slides/slide83.xml><?xml version="1.0" encoding="utf-8"?>
+<file path=ppt/slides/slide81.xml><?xml version="1.0" encoding="utf-8"?>
 <p:sld xmlns:a="http://schemas.openxmlformats.org/drawingml/2006/main" xmlns:r="http://schemas.openxmlformats.org/officeDocument/2006/relationships" xmlns:p="http://schemas.openxmlformats.org/presentationml/2006/main">
   <p:cSld>
     <p:spTree>
@@ -31018,7 +31008,7 @@
 </p:sld>
 </file>
 
-<file path=ppt/slides/slide84.xml><?xml version="1.0" encoding="utf-8"?>
+<file path=ppt/slides/slide82.xml><?xml version="1.0" encoding="utf-8"?>
 <p:sld xmlns:a="http://schemas.openxmlformats.org/drawingml/2006/main" xmlns:r="http://schemas.openxmlformats.org/officeDocument/2006/relationships" xmlns:p="http://schemas.openxmlformats.org/presentationml/2006/main">
   <p:cSld>
     <p:spTree>
@@ -31095,7 +31085,7 @@
 </p:sld>
 </file>
 
-<file path=ppt/slides/slide85.xml><?xml version="1.0" encoding="utf-8"?>
+<file path=ppt/slides/slide83.xml><?xml version="1.0" encoding="utf-8"?>
 <p:sld xmlns:a="http://schemas.openxmlformats.org/drawingml/2006/main" xmlns:r="http://schemas.openxmlformats.org/officeDocument/2006/relationships" xmlns:p="http://schemas.openxmlformats.org/presentationml/2006/main">
   <p:cSld>
     <p:spTree>
@@ -31171,7 +31161,7 @@
 </p:sld>
 </file>
 
-<file path=ppt/slides/slide86.xml><?xml version="1.0" encoding="utf-8"?>
+<file path=ppt/slides/slide84.xml><?xml version="1.0" encoding="utf-8"?>
 <p:sld xmlns:a="http://schemas.openxmlformats.org/drawingml/2006/main" xmlns:r="http://schemas.openxmlformats.org/officeDocument/2006/relationships" xmlns:p="http://schemas.openxmlformats.org/presentationml/2006/main">
   <p:cSld>
     <p:spTree>
@@ -31248,7 +31238,7 @@
 </p:sld>
 </file>
 
-<file path=ppt/slides/slide87.xml><?xml version="1.0" encoding="utf-8"?>
+<file path=ppt/slides/slide85.xml><?xml version="1.0" encoding="utf-8"?>
 <p:sld xmlns:a="http://schemas.openxmlformats.org/drawingml/2006/main" xmlns:r="http://schemas.openxmlformats.org/officeDocument/2006/relationships" xmlns:p="http://schemas.openxmlformats.org/presentationml/2006/main">
   <p:cSld>
     <p:spTree>
@@ -31324,7 +31314,7 @@
 </p:sld>
 </file>
 
-<file path=ppt/slides/slide88.xml><?xml version="1.0" encoding="utf-8"?>
+<file path=ppt/slides/slide86.xml><?xml version="1.0" encoding="utf-8"?>
 <p:sld xmlns:a="http://schemas.openxmlformats.org/drawingml/2006/main" xmlns:r="http://schemas.openxmlformats.org/officeDocument/2006/relationships" xmlns:p="http://schemas.openxmlformats.org/presentationml/2006/main">
   <p:cSld>
     <p:spTree>
@@ -31401,7 +31391,7 @@
 </p:sld>
 </file>
 
-<file path=ppt/slides/slide89.xml><?xml version="1.0" encoding="utf-8"?>
+<file path=ppt/slides/slide87.xml><?xml version="1.0" encoding="utf-8"?>
 <p:sld xmlns:a="http://schemas.openxmlformats.org/drawingml/2006/main" xmlns:r="http://schemas.openxmlformats.org/officeDocument/2006/relationships" xmlns:p="http://schemas.openxmlformats.org/presentationml/2006/main">
   <p:cSld>
     <p:spTree>
@@ -31426,7 +31416,7 @@
         </p:nvGraphicFramePr>
         <p:xfrm>
           <a:off x="952500" y="895375"/>
-          <a:ext cx="3000000" cy="3000000"/>
+          <a:ext cx="7239000" cy="3505140"/>
         </p:xfrm>
         <a:graphic>
           <a:graphicData uri="http://schemas.openxmlformats.org/drawingml/2006/table">
@@ -31885,6 +31875,155 @@
 </p:sld>
 </file>
 
+<file path=ppt/slides/slide88.xml><?xml version="1.0" encoding="utf-8"?>
+<p:sld xmlns:a="http://schemas.openxmlformats.org/drawingml/2006/main" xmlns:r="http://schemas.openxmlformats.org/officeDocument/2006/relationships" xmlns:p="http://schemas.openxmlformats.org/presentationml/2006/main">
+  <p:cSld>
+    <p:spTree>
+      <p:nvGrpSpPr>
+        <p:cNvPr id="1" name="Shape 623"/>
+        <p:cNvGrpSpPr/>
+        <p:nvPr/>
+      </p:nvGrpSpPr>
+      <p:grpSpPr>
+        <a:xfrm>
+          <a:off x="0" y="0"/>
+          <a:ext cx="0" cy="0"/>
+          <a:chOff x="0" y="0"/>
+          <a:chExt cx="0" cy="0"/>
+        </a:xfrm>
+      </p:grpSpPr>
+      <p:sp>
+        <p:nvSpPr>
+          <p:cNvPr id="624" name="Google Shape;624;p105"/>
+          <p:cNvSpPr txBox="1">
+            <a:spLocks noGrp="1"/>
+          </p:cNvSpPr>
+          <p:nvPr>
+            <p:ph type="title"/>
+          </p:nvPr>
+        </p:nvSpPr>
+        <p:spPr>
+          <a:xfrm>
+            <a:off x="311700" y="2150850"/>
+            <a:ext cx="8520600" cy="841800"/>
+          </a:xfrm>
+          <a:prstGeom prst="rect">
+            <a:avLst/>
+          </a:prstGeom>
+        </p:spPr>
+        <p:txBody>
+          <a:bodyPr spcFirstLastPara="1" wrap="square" lIns="91425" tIns="91425" rIns="91425" bIns="91425" anchor="ctr" anchorCtr="0">
+            <a:noAutofit/>
+          </a:bodyPr>
+          <a:lstStyle/>
+          <a:p>
+            <a:pPr marL="0" lvl="0" indent="0" algn="ctr" rtl="0">
+              <a:spcBef>
+                <a:spcPts val="0"/>
+              </a:spcBef>
+              <a:spcAft>
+                <a:spcPts val="0"/>
+              </a:spcAft>
+              <a:buNone/>
+            </a:pPr>
+            <a:r>
+              <a:rPr lang="en" sz="2500">
+                <a:uFill>
+                  <a:noFill/>
+                </a:uFill>
+                <a:hlinkClick r:id="rId3"/>
+              </a:rPr>
+              <a:t>docs.python.org/3/library/stdtypes.html#mapping-types-dict</a:t>
+            </a:r>
+            <a:endParaRPr sz="2500"/>
+          </a:p>
+        </p:txBody>
+      </p:sp>
+    </p:spTree>
+  </p:cSld>
+  <p:clrMapOvr>
+    <a:masterClrMapping/>
+  </p:clrMapOvr>
+</p:sld>
+</file>
+
+<file path=ppt/slides/slide89.xml><?xml version="1.0" encoding="utf-8"?>
+<p:sld xmlns:a="http://schemas.openxmlformats.org/drawingml/2006/main" xmlns:r="http://schemas.openxmlformats.org/officeDocument/2006/relationships" xmlns:p="http://schemas.openxmlformats.org/presentationml/2006/main">
+  <p:cSld>
+    <p:spTree>
+      <p:nvGrpSpPr>
+        <p:cNvPr id="1" name="Shape 628"/>
+        <p:cNvGrpSpPr/>
+        <p:nvPr/>
+      </p:nvGrpSpPr>
+      <p:grpSpPr>
+        <a:xfrm>
+          <a:off x="0" y="0"/>
+          <a:ext cx="0" cy="0"/>
+          <a:chOff x="0" y="0"/>
+          <a:chExt cx="0" cy="0"/>
+        </a:xfrm>
+      </p:grpSpPr>
+      <p:sp>
+        <p:nvSpPr>
+          <p:cNvPr id="629" name="Google Shape;629;p106"/>
+          <p:cNvSpPr txBox="1">
+            <a:spLocks noGrp="1"/>
+          </p:cNvSpPr>
+          <p:nvPr>
+            <p:ph type="title"/>
+          </p:nvPr>
+        </p:nvSpPr>
+        <p:spPr>
+          <a:xfrm>
+            <a:off x="311700" y="2150850"/>
+            <a:ext cx="8520600" cy="841800"/>
+          </a:xfrm>
+          <a:prstGeom prst="rect">
+            <a:avLst/>
+          </a:prstGeom>
+        </p:spPr>
+        <p:txBody>
+          <a:bodyPr spcFirstLastPara="1" wrap="square" lIns="91425" tIns="91425" rIns="91425" bIns="91425" anchor="ctr" anchorCtr="0">
+            <a:noAutofit/>
+          </a:bodyPr>
+          <a:lstStyle/>
+          <a:p>
+            <a:pPr marL="0" lvl="0" indent="0" algn="ctr" rtl="0">
+              <a:spcBef>
+                <a:spcPts val="0"/>
+              </a:spcBef>
+              <a:spcAft>
+                <a:spcPts val="0"/>
+              </a:spcAft>
+              <a:buNone/>
+            </a:pPr>
+            <a:r>
+              <a:rPr lang="en">
+                <a:latin typeface="Consolas"/>
+                <a:ea typeface="Consolas"/>
+                <a:cs typeface="Consolas"/>
+                <a:sym typeface="Consolas"/>
+              </a:rPr>
+              <a:t>sys</a:t>
+            </a:r>
+            <a:endParaRPr>
+              <a:latin typeface="Consolas"/>
+              <a:ea typeface="Consolas"/>
+              <a:cs typeface="Consolas"/>
+              <a:sym typeface="Consolas"/>
+            </a:endParaRPr>
+          </a:p>
+        </p:txBody>
+      </p:sp>
+    </p:spTree>
+  </p:cSld>
+  <p:clrMapOvr>
+    <a:masterClrMapping/>
+  </p:clrMapOvr>
+</p:sld>
+</file>
+
 <file path=ppt/slides/slide9.xml><?xml version="1.0" encoding="utf-8"?>
 <p:sld xmlns:a="http://schemas.openxmlformats.org/drawingml/2006/main" xmlns:r="http://schemas.openxmlformats.org/officeDocument/2006/relationships" xmlns:p="http://schemas.openxmlformats.org/presentationml/2006/main">
   <p:cSld>
@@ -31957,155 +32096,6 @@
   <p:cSld>
     <p:spTree>
       <p:nvGrpSpPr>
-        <p:cNvPr id="1" name="Shape 623"/>
-        <p:cNvGrpSpPr/>
-        <p:nvPr/>
-      </p:nvGrpSpPr>
-      <p:grpSpPr>
-        <a:xfrm>
-          <a:off x="0" y="0"/>
-          <a:ext cx="0" cy="0"/>
-          <a:chOff x="0" y="0"/>
-          <a:chExt cx="0" cy="0"/>
-        </a:xfrm>
-      </p:grpSpPr>
-      <p:sp>
-        <p:nvSpPr>
-          <p:cNvPr id="624" name="Google Shape;624;p105"/>
-          <p:cNvSpPr txBox="1">
-            <a:spLocks noGrp="1"/>
-          </p:cNvSpPr>
-          <p:nvPr>
-            <p:ph type="title"/>
-          </p:nvPr>
-        </p:nvSpPr>
-        <p:spPr>
-          <a:xfrm>
-            <a:off x="311700" y="2150850"/>
-            <a:ext cx="8520600" cy="841800"/>
-          </a:xfrm>
-          <a:prstGeom prst="rect">
-            <a:avLst/>
-          </a:prstGeom>
-        </p:spPr>
-        <p:txBody>
-          <a:bodyPr spcFirstLastPara="1" wrap="square" lIns="91425" tIns="91425" rIns="91425" bIns="91425" anchor="ctr" anchorCtr="0">
-            <a:noAutofit/>
-          </a:bodyPr>
-          <a:lstStyle/>
-          <a:p>
-            <a:pPr marL="0" lvl="0" indent="0" algn="ctr" rtl="0">
-              <a:spcBef>
-                <a:spcPts val="0"/>
-              </a:spcBef>
-              <a:spcAft>
-                <a:spcPts val="0"/>
-              </a:spcAft>
-              <a:buNone/>
-            </a:pPr>
-            <a:r>
-              <a:rPr lang="en" sz="2500">
-                <a:uFill>
-                  <a:noFill/>
-                </a:uFill>
-                <a:hlinkClick r:id="rId3"/>
-              </a:rPr>
-              <a:t>docs.python.org/3/library/stdtypes.html#mapping-types-dict</a:t>
-            </a:r>
-            <a:endParaRPr sz="2500"/>
-          </a:p>
-        </p:txBody>
-      </p:sp>
-    </p:spTree>
-  </p:cSld>
-  <p:clrMapOvr>
-    <a:masterClrMapping/>
-  </p:clrMapOvr>
-</p:sld>
-</file>
-
-<file path=ppt/slides/slide91.xml><?xml version="1.0" encoding="utf-8"?>
-<p:sld xmlns:a="http://schemas.openxmlformats.org/drawingml/2006/main" xmlns:r="http://schemas.openxmlformats.org/officeDocument/2006/relationships" xmlns:p="http://schemas.openxmlformats.org/presentationml/2006/main">
-  <p:cSld>
-    <p:spTree>
-      <p:nvGrpSpPr>
-        <p:cNvPr id="1" name="Shape 628"/>
-        <p:cNvGrpSpPr/>
-        <p:nvPr/>
-      </p:nvGrpSpPr>
-      <p:grpSpPr>
-        <a:xfrm>
-          <a:off x="0" y="0"/>
-          <a:ext cx="0" cy="0"/>
-          <a:chOff x="0" y="0"/>
-          <a:chExt cx="0" cy="0"/>
-        </a:xfrm>
-      </p:grpSpPr>
-      <p:sp>
-        <p:nvSpPr>
-          <p:cNvPr id="629" name="Google Shape;629;p106"/>
-          <p:cNvSpPr txBox="1">
-            <a:spLocks noGrp="1"/>
-          </p:cNvSpPr>
-          <p:nvPr>
-            <p:ph type="title"/>
-          </p:nvPr>
-        </p:nvSpPr>
-        <p:spPr>
-          <a:xfrm>
-            <a:off x="311700" y="2150850"/>
-            <a:ext cx="8520600" cy="841800"/>
-          </a:xfrm>
-          <a:prstGeom prst="rect">
-            <a:avLst/>
-          </a:prstGeom>
-        </p:spPr>
-        <p:txBody>
-          <a:bodyPr spcFirstLastPara="1" wrap="square" lIns="91425" tIns="91425" rIns="91425" bIns="91425" anchor="ctr" anchorCtr="0">
-            <a:noAutofit/>
-          </a:bodyPr>
-          <a:lstStyle/>
-          <a:p>
-            <a:pPr marL="0" lvl="0" indent="0" algn="ctr" rtl="0">
-              <a:spcBef>
-                <a:spcPts val="0"/>
-              </a:spcBef>
-              <a:spcAft>
-                <a:spcPts val="0"/>
-              </a:spcAft>
-              <a:buNone/>
-            </a:pPr>
-            <a:r>
-              <a:rPr lang="en">
-                <a:latin typeface="Consolas"/>
-                <a:ea typeface="Consolas"/>
-                <a:cs typeface="Consolas"/>
-                <a:sym typeface="Consolas"/>
-              </a:rPr>
-              <a:t>sys</a:t>
-            </a:r>
-            <a:endParaRPr>
-              <a:latin typeface="Consolas"/>
-              <a:ea typeface="Consolas"/>
-              <a:cs typeface="Consolas"/>
-              <a:sym typeface="Consolas"/>
-            </a:endParaRPr>
-          </a:p>
-        </p:txBody>
-      </p:sp>
-    </p:spTree>
-  </p:cSld>
-  <p:clrMapOvr>
-    <a:masterClrMapping/>
-  </p:clrMapOvr>
-</p:sld>
-</file>
-
-<file path=ppt/slides/slide92.xml><?xml version="1.0" encoding="utf-8"?>
-<p:sld xmlns:a="http://schemas.openxmlformats.org/drawingml/2006/main" xmlns:r="http://schemas.openxmlformats.org/officeDocument/2006/relationships" xmlns:p="http://schemas.openxmlformats.org/presentationml/2006/main">
-  <p:cSld>
-    <p:spTree>
-      <p:nvGrpSpPr>
         <p:cNvPr id="1" name="Shape 633"/>
         <p:cNvGrpSpPr/>
         <p:nvPr/>
@@ -32177,7 +32167,7 @@
 </p:sld>
 </file>
 
-<file path=ppt/slides/slide93.xml><?xml version="1.0" encoding="utf-8"?>
+<file path=ppt/slides/slide91.xml><?xml version="1.0" encoding="utf-8"?>
 <p:sld xmlns:a="http://schemas.openxmlformats.org/drawingml/2006/main" xmlns:r="http://schemas.openxmlformats.org/officeDocument/2006/relationships" xmlns:p="http://schemas.openxmlformats.org/presentationml/2006/main">
   <p:cSld>
     <p:spTree>
@@ -32254,7 +32244,7 @@
 </p:sld>
 </file>
 
-<file path=ppt/slides/slide94.xml><?xml version="1.0" encoding="utf-8"?>
+<file path=ppt/slides/slide92.xml><?xml version="1.0" encoding="utf-8"?>
 <p:sld xmlns:a="http://schemas.openxmlformats.org/drawingml/2006/main" xmlns:r="http://schemas.openxmlformats.org/officeDocument/2006/relationships" xmlns:p="http://schemas.openxmlformats.org/presentationml/2006/main">
   <p:cSld>
     <p:spTree>
@@ -32330,7 +32320,7 @@
 </p:sld>
 </file>
 
-<file path=ppt/slides/slide95.xml><?xml version="1.0" encoding="utf-8"?>
+<file path=ppt/slides/slide93.xml><?xml version="1.0" encoding="utf-8"?>
 <p:sld xmlns:a="http://schemas.openxmlformats.org/drawingml/2006/main" xmlns:r="http://schemas.openxmlformats.org/officeDocument/2006/relationships" xmlns:p="http://schemas.openxmlformats.org/presentationml/2006/main">
   <p:cSld>
     <p:spTree>
@@ -32407,7 +32397,7 @@
 </p:sld>
 </file>
 
-<file path=ppt/slides/slide96.xml><?xml version="1.0" encoding="utf-8"?>
+<file path=ppt/slides/slide94.xml><?xml version="1.0" encoding="utf-8"?>
 <p:sld xmlns:a="http://schemas.openxmlformats.org/drawingml/2006/main" xmlns:r="http://schemas.openxmlformats.org/officeDocument/2006/relationships" xmlns:p="http://schemas.openxmlformats.org/presentationml/2006/main">
   <p:cSld>
     <p:spTree>

</xml_diff>

<commit_message>
Update module schedule to include lecture link for Python in week 7 and enhance slides_7.pptx for improved content delivery.
</commit_message>
<xml_diff>
--- a/lectures/slides_7.pptx
+++ b/lectures/slides_7.pptx
@@ -351,6 +351,113 @@
     </p:ext>
   </p:extLst>
 </p:presentation>
+</file>
+
+<file path=ppt/ink/ink1.xml><?xml version="1.0" encoding="utf-8"?>
+<inkml:ink xmlns:inkml="http://www.w3.org/2003/InkML">
+  <inkml:definitions>
+    <inkml:context xml:id="ctx0">
+      <inkml:inkSource xml:id="inkSrc0">
+        <inkml:traceFormat>
+          <inkml:channel name="X" type="integer" max="32767" units="cm"/>
+          <inkml:channel name="Y" type="integer" max="32767" units="cm"/>
+          <inkml:channel name="F" type="integer" max="8191" units="deg"/>
+          <inkml:channel name="T" type="integer" max="2.14748E9" units="dev"/>
+        </inkml:traceFormat>
+        <inkml:channelProperties>
+          <inkml:channelProperty channel="X" name="resolution" value="2053.07007" units="1/cm"/>
+          <inkml:channelProperty channel="Y" name="resolution" value="3286.55957" units="1/cm"/>
+          <inkml:channelProperty channel="F" name="resolution" value="22.75278" units="1/deg"/>
+          <inkml:channelProperty channel="T" name="resolution" value="1" units="1/dev"/>
+        </inkml:channelProperties>
+      </inkml:inkSource>
+      <inkml:timestamp xml:id="ts0" timeString="2025-11-07T13:59:35.455"/>
+    </inkml:context>
+    <inkml:brush xml:id="br0">
+      <inkml:brushProperty name="width" value="0.05292" units="cm"/>
+      <inkml:brushProperty name="height" value="0.05292" units="cm"/>
+      <inkml:brushProperty name="color" value="#FF0000"/>
+    </inkml:brush>
+  </inkml:definitions>
+  <inkml:trace contextRef="#ctx0" brushRef="#br0">14248 5378 176 0,'0'0'69'0,"0"0"-63"0,0 0 790 0,0 0-100 0,0 0-290 0,0 0-199 0,0 0-16 0,0 0 5 0,0 0-31 0,-45 7-60 0,45-7-5 0,0-1 5 16,0-2 4-16,0 0-17 0,0 1-28 16,0 1-20-16,0 1-12 0,0 0-7 15,0 0-9-15,0 0-16 0,0 0-2 16,0 0 2-16,3 0 18 0,0 0 23 15,3 0 9-15,0 0 20 0,7 0 31 16,7-4 15-16,14-10-18 0,33-16-39 0,44-25-37 16,23-15-7-16,19-10-15 0,-4-4-18 15,-8 8-20-15,-2 3-50 0,-2 1 6 16,-2 3 1-16,-11 5 15 0,-23 7 37 16,-21 13-59-16,-26 10-20 0,-26 12 13 15,-15 8-32-15,-13 6-23 0,0 8-10 16,-25 0-97-16,-29 10-311 0,-28 8-463 15,7-1-26-15</inkml:trace>
+  <inkml:trace contextRef="#ctx0" brushRef="#br0" timeOffset="4170.6">12840 6933 46 0,'0'0'225'0,"0"0"-170"0,0 0 131 15,0 0 401-15,0 0-125 0,0 0-127 16,0 0-102-16,0 0-16 0,-12 4-55 15,12-4-85-15,0 0 14 0,0 0 25 16,0 0-16-16,0 0-24 0,0 0 1 0,0 0 0 16,0 0-3-16,0 0-23 15,0 0-10-15,0 0 4 0,0 0 9 0,0 0-3 16,0 0 3-16,0 0 16 0,0 0 12 16,0 0-6-16,6 0-3 0,3 0 2 15,3-3-18-15,27-7-57 0,40-12-22 16,56-19 19-16,36-13-13 0,24-8-31 15,-4-3-29-15,-29 10-6 0,-10 3 19 16,-18 7-64-16,-20 10-64 0,-21 5-62 0,-17 5-181 16,-15 4-194-16,-16 4-97 0,-17 5-73 15</inkml:trace>
+  <inkml:trace contextRef="#ctx0" brushRef="#br0" timeOffset="6755.14">7992 7684 72 0,'0'0'78'0,"0"0"46"0,0 0-105 0,0 0 17 0,0 0 424 16,0 0 312-16,0 0-421 0,0 0-127 16,163 17 25-16,-138-20-7 0,10-1-52 15,1-2-16-15,-2-2-17 0,2 1-52 16,-5 1-105-16,1-3-9 0,-7-1-183 15,-9 0-181-15,-6-4-199 0,-6 4-658 16</inkml:trace>
+  <inkml:trace contextRef="#ctx0" brushRef="#br0" timeOffset="7441.3">8212 9097 147 0,'0'0'107'0,"0"0"-35"0,0 0 681 0,0 0-173 16,0 0-304-16,0 0-153 0,0 0 75 15,0 0 22-15,0 0 2 0,0 0-16 16,22 14-29-16,-19-14-40 0,0 0-38 15,5 0-32-15,1 0-22 0,7 0-14 16,5 0 14-16,18 5-7 0,15 0-35 16,13 4 0-16,9 1-2 0,8-1-1 0,-8 0-20 15,-10-3-50-15,-5-6-28 16,-16 0-126-16,-17 0-238 0,-16-6-647 0,-12-5-458 0</inkml:trace>
+  <inkml:trace contextRef="#ctx0" brushRef="#br0" timeOffset="9075.17">9176 8832 150 0,'0'0'62'0,"0"0"-36"0,0 0-26 15,0 0 20-15,0 0 77 0,0 0 568 16,0 0-290-16,0 0-76 0,163 18-91 16,-144-20-91-16,3-2 6 0,1 2-22 15,-5-1-20-15,-2 0-13 0,1 1 0 16,-8 1-17-16,1 1-25 0,-1-1-24 16,-3 1-1-16,-3 0 44 0,3 0-12 0,1 0-33 15,10 0 0-15,1 0 26 0,15 0-10 16,24 2-3-16,28 4 24 0,24 0-36 15,15 3 50-15,9-1-19 0,-2-1 39 16,-1 2-23-16,-2-2-16 0,-7 0-32 16,-11 0-29-16,-10 0-161 0,-10-1-81 15,-18-4-56-15,-17-2-14 0,-18 0-143 16,-14-8-184-16,-14 4 55 0</inkml:trace>
+  <inkml:trace contextRef="#ctx0" brushRef="#br0" timeOffset="10858.99">11834 8833 42 0,'0'0'0'0,"0"0"0"0,0 0 43 16,0 0-42-16,0 0 1 0,0 0 24 15,0 0-3-15,0 0 0 0,0 0-7 16,0 0-14-16,20-1 11 0,-20 1-9 0,0 0-3 16,0 0 1-16,0 0 14 0,3 0 4 15,-3 0-20-15,3 0 0 0,0 0-1 16,0 0 1-16,4 0-1 0,-1 0 1 16,0 0 19-16,-3 0 170 0,0 0-52 15,-3 0-62-15,0 0-29 0,0 0-4 16,0 0 1-16,0 0 25 0,0 0 36 15,0 0 53-15,0 0-4 0,0 0-36 0,0 0-58 16,3 0-57-16,-3 0-2 0,0 0-2 16,3 0 2-16,0 1 2 0,-3 0 40 15,4 1-19-15,0 0-22 0,-1-1 2 16,0 0 0-16,0-1 1 0,4 2 38 16,-1-1 59-16,3 0-13 0,4 1 3 15,4 0-23-15,-2-1 16 0,7 2-13 16,4-2 4-16,-1 2-20 0,8-1 16 15,7 0-9-15,11 1-1 0,9 0-15 16,1 0-8-16,-1-2-5 0,-8-1-17 0,-14 0 10 16,-7 0-4-16,5 0-7 0,1 0-14 15,14-1 27-15,-3 0-24 0,-12-1 5 16,-11 2-5-16,-10 0-4 0,12 0-1 16,-6 0-67-16,-2 0-65 0,1 0-74 15,-10 2-62-15,-4-1-154 0,-6-1-176 16,0 0-36-16</inkml:trace>
+  <inkml:trace contextRef="#ctx0" brushRef="#br0" timeOffset="11610.74">14792 8852 62 0,'0'0'78'16,"0"0"-76"-16,0 0 64 0,0 0 178 0,0 0 317 15,0 0-327-15,0 0 30 0,0 0-7 16,0 0-75-16,0 0 0 0,115 64 12 16,-75-62 19-16,11-2-39 0,16 0-74 15,6-2-48-15,4-2-39 0,-4 1 12 16,0 1 11-16,-3 1-36 0,-1 0-16 0,3 1-52 16,-9-2-54-16,-2 1-81 0,-18-1-140 15,-7-2-268-15,-18 0-511 0,-15-2 668 16</inkml:trace>
+  <inkml:trace contextRef="#ctx0" brushRef="#br0" timeOffset="13143.53">16803 7934 59 0,'0'0'0'0,"0"0"-59"0,0 0 59 0,0 0 3 15,0 0 17-15,0 0-7 0,0 0 52 16,0 0-29-16,0 0-7 0,0 0 128 0,-61 25 35 16,58-25 199-16,0 0-120 0,0 0-102 15,0 0-9-15,0 0 12 0,0 0-29 16,-1 0-78-16,-2 0-65 0,-3 0-11 15,-2 5 11-15,-4-1 1 0,2 3 32 16,1-1-33-16,-2 1 13 0,8 0-10 16,-4 0 42-16,1 1-22 0,0 2-10 15,-1 0 0-15,4 2-12 0,-5 0 1 0,8 1 40 16,-3-2-3-16,0 3 26 0,0 3 23 16,-1 6-20-16,1 4-4 0,-3 3-34 15,3-4 12-15,3-4-17 0,-5-8-21 16,8-3-4-16,0-5 1 0,0 3 2 15,0 0-3-15,14-1 39 0,-2 0-10 16,7-1-27-16,-1 0 27 0,9-3-6 16,-2 0 9-16,13-2-29 0,10-2 13 15,13-10-6-15,9-7-10 0,-4-3-52 0,-5-2-74 16,-7 2 7-16,-6 3 57 0,-14 3-9 16,-4 2-7-16,-9 3 46 0,-8 1 31 15,7-1 1-15,-8 0 18 0,4-1-17 16,-7 1 15-16,2 4 49 0,-8-2 39 15,-3 1 25-15,0-1-32 0,0 0-36 16,-14-2-32-16,-1 1 4 0,-7-2-4 16,-8-2 1-16,-7 0-30 0,-14-5-13 0,-12-3-7 15,-4 0-12-15,13 3 30 0,12 5-59 16,17 3 30-16,2 2 31 0,1-2 29 16,-4 1 45-16,4-2-16 0,3 1-44 15,2 3-12-15,8 0-4 0,0 2 1 16,-1 1-67-16,1 0-135 0,3 2-30 15,3-1 55-15,3 1-24 0,0-2-207 16,0-1-321-16,0-5 176 0</inkml:trace>
+  <inkml:trace contextRef="#ctx0" brushRef="#br0" timeOffset="15044.85">16243 7979 29 0,'0'0'20'0,"0"0"22"0,0 0-22 0,0 0-1 16,0 0 259-16,0 0 269 0,0 0-201 0,0 0-190 16,0 0-107-16,-33-7-23 0,21 3 29 15,3 1 59-15,-4-2-56 0,-1 3 43 16,5-3 9-16,-3 4-19 0,2-2-10 16,-2 0-77-16,-1 2 2 0,-4-1-6 15,2 1-3-15,-1-1 3 0,-1 2 4 16,2 0-2-16,-1 0-4 0,1 0-8 0,1 0-25 15,2 3 15-15,-1 2 20 0,1-1 13 16,2 2-10-16,-7 0 0 0,5-1 42 16,0 2 30-16,-4 3-20 0,-4-1-23 15,4 1-6-15,1 1-26 0,-4-1-1 16,2 2-2-16,5-3-1 0,-4 1-16 16,7-2 18-16,-5 1-12 0,5-1 13 15,-1 2 2-15,1 2-2 0,0-1-15 0,3 1 15 16,-1-1-15-16,0 0 3 0,4 1 12 15,3 0-12-15,0-1 13 0,0 2 33 16,0 0-17-16,0 2 3 0,3 1 7 16,8 1-24-16,-2 4 0 0,6 3-1 15,1-4 2-15,1 0-1 0,-5-4-1 16,4-2 1-16,-1 1-1 0,5 2 2 16,2 0 0-16,-3-3-1 0,1 2-2 0,-1 0 1 15,-1 1-1-15,2-2 0 16,-1 3 1-16,-4-2 1 0,1-1-2 0,4 1-1 15,-4 0 1-15,-1-2 3 0,2 0 17 16,2 1-1-16,-4 0 23 0,4-3 3 16,4 2-9-16,-1-2 6 0,1-1-16 15,-1-2 16-15,-1-1-26 0,3-2 19 16,-3-2 10-16,-2-1-13 0,1 1-28 16,-1-3 12-16,-4-1-13 0,2 0 10 15,-1 0-10-15,-4 0 16 0,4-1-3 0,4-4 1 16,-1 1-14-16,2-4 19 0,6 2 7 15,-6 0-13-15,1-2-14 0,1 3 24 16,-1-2 3-16,1-1-10 0,-1 1-16 16,-3 0 23-16,-2-1 13 0,-2-1-20 15,1-1-19-15,-4-1 2 0,2-1 1 16,-2 0 13-16,-2 1-15 0,-4-2 1 16,0 2 9-16,0-2-11 0,0 0 0 15,-2-1 0-15,-4-1 0 0,3 1-2 16,0-1-9-16,-3 2 11 0,0-1 3 0,0 3 58 15,0-1 3-15,0 2 13 0,0 2-7 16,-6-1-23-16,-4 0-18 0,-5 1-29 16,-1-3-23-16,-4 0-31 0,-5-1-23 15,-4-3 32-15,1 0-2 0,-8-4 2 16,-7-7 7-16,-5-3-1 0,-3-3 17 16,9 0-68-16,5 3-10 0,10 5-28 15,5 0 21-15,7 5 56 0,1 4 47 0,8 2 3 16,3 3 1-16,-3-1-1 15,-1 1-28-15,-2-3-35 0,3 3-1 0,-3 2-29 16,-5 2-42-16,4 0-136 0,-8 1-105 16,-1-1-196-16,-7-1-60 0</inkml:trace>
+  <inkml:trace contextRef="#ctx0" brushRef="#br0" timeOffset="17897.27">17440 8067 53 0,'0'0'157'0,"0"0"-76"0,0 0-48 0,0 0 52 0,0 0-17 16,0 0-68-16,0 0 3 0,0 0-3 15,-48 35 40-15,45-29-14 0,3 0-25 16,-3-1 38-16,3 1-7 0,-4 1 37 16,-2 0-23-16,0 1 9 0,-5 2-42 15,2 0 42-15,0 3-17 0,-4 1-38 16,-2 3 0-16,-6 4 38 0,3 7-8 0,2 1-30 15,4-1-20-15,1-1 17 16,8-2 3-16,-3-1 24 0,0-1 562 0,-1-1-297 16,4 0-123-16,0 1-101 0,3 1 81 15,0 0-30-15,0-1-77 0,0 0 6 16,0-2-19-16,3 1 3 0,4-2 23 16,-1-4-10-16,3-4 16 0,0 0-3 15,2-4 6-15,5 3-9 0,-1 4-20 16,4 0-6-16,4-1-23 0,-4-1 32 15,4-3 23-15,-1 0-13 0,-1-3 3 0,3-1-6 16,0-2 6-16,-5-1-26 16,7-2 13-16,-7-1 13 0,0 0-19 0,4-3 22 15,-1-4 35-15,7-6-13 0,5-8-32 16,8-7-25-16,0-2 6 0,-5 0-21 16,-1 0 3-16,-8 3 18 0,1 0-19 15,-4-2-3-15,-5 4-2 0,-5-2 2 16,-2 3 2-16,-7 1 10 0,-6 1-8 15,0 1 8-15,-6 0 23 0,-13-1-33 16,-1-1-1-16,-2 1 25 0,-2-2 25 0,0-1-51 16,0 0-1-16,0 1-2 0,3 0 1 15,-1-1-20-15,-1 1-45 0,1 1 4 16,0-1-32-16,2 1 63 0,5 5-22 16,2 3 51-16,7 4-13 0,-3 0 22 15,-2 3-6-15,5-3 2 0,-4 3 12 16,-2 1-14-16,0 3-51 0,-2 2-38 15,4 1-103-15,-2 1 12 0,3 0-55 0,-1 0-146 16,4 0-145-16,3 0-245 0,-3 0-191 16</inkml:trace>
+</inkml:ink>
+</file>
+
+<file path=ppt/ink/ink2.xml><?xml version="1.0" encoding="utf-8"?>
+<inkml:ink xmlns:inkml="http://www.w3.org/2003/InkML">
+  <inkml:definitions>
+    <inkml:context xml:id="ctx0">
+      <inkml:inkSource xml:id="inkSrc0">
+        <inkml:traceFormat>
+          <inkml:channel name="X" type="integer" max="32767" units="cm"/>
+          <inkml:channel name="Y" type="integer" max="32767" units="cm"/>
+          <inkml:channel name="F" type="integer" max="8191" units="deg"/>
+          <inkml:channel name="T" type="integer" max="2.14748E9" units="dev"/>
+        </inkml:traceFormat>
+        <inkml:channelProperties>
+          <inkml:channelProperty channel="X" name="resolution" value="2053.07007" units="1/cm"/>
+          <inkml:channelProperty channel="Y" name="resolution" value="3286.55957" units="1/cm"/>
+          <inkml:channelProperty channel="F" name="resolution" value="22.75278" units="1/deg"/>
+          <inkml:channelProperty channel="T" name="resolution" value="1" units="1/dev"/>
+        </inkml:channelProperties>
+      </inkml:inkSource>
+      <inkml:timestamp xml:id="ts0" timeString="2025-11-07T14:00:14.086"/>
+    </inkml:context>
+    <inkml:brush xml:id="br0">
+      <inkml:brushProperty name="width" value="0.05292" units="cm"/>
+      <inkml:brushProperty name="height" value="0.05292" units="cm"/>
+      <inkml:brushProperty name="color" value="#FF0000"/>
+    </inkml:brush>
+  </inkml:definitions>
+  <inkml:trace contextRef="#ctx0" brushRef="#br0">7601 7714 398 0,'0'0'244'0,"0"0"-152"0,0 0 142 0,0 0-87 0,0 0-147 15,0 0 0-15,0 0 16 0,0 0 414 16,0 0-297-16,13-13-35 0,-10 13-43 15,0-2-19-15,0 1-33 0,0 0-3 16,0 1 10-16,0-2-10 0,0 1 0 16,1 1 26-16,-4 0-24 0,0 0 11 15,0 0-10-15,0 0 20 0,0 0 3 16,0 0-8-16,0 0-17 0,0 0 1 16,3 0-2-16,-3 0 107 0,0 0 224 15,0 0-141-15,0 0-125 0,3 0-49 0,1 0-3 16,3 1 3-16,-1 2 58 0,9 2 29 15,1-1-14-15,10 2-2 0,8-2-1 16,21 0 39-16,17 0 15 0,25 0-7 16,8-3 0-16,10 0-4 0,2-1 31 15,1 0-46-15,3 2-42 0,-3 0-13 16,-11 2-16-16,-2-2-21 0,-12 3-22 16,-10-4-15-16,-14 2-29 0,-14-2-9 0,-17 1-37 15,-13-2 7-15,-6 0-20 0,4 0-26 16,-4-3-45-16,-1-4-61 0,-1-2-122 15,-7-1-129-15,-1 1-289 0,-9-8-532 0</inkml:trace>
+  <inkml:trace contextRef="#ctx0" brushRef="#br0" timeOffset="4584.99">9682 6829 54 0,'0'0'0'0,"0"0"-4"0,0 0 4 0,0 0 29 0,0 0 37 16,0 0-31-16,0 0 207 0,-9 0 403 16,5 0-348-16,1-4-132 0,-3 3 14 15,3-2-10-15,0 1-26 0,-3-2-7 16,3 2 4-16,0 1-34 0,-1-3-18 15,1 1-4-15,0 1-33 0,0-1-31 16,-1 1-19-16,0-1 0 0,1 1-1 0,-3-2-2 16,3 3 2-16,0 0-1 0,0 1 1 15,-3 0 19-15,-4 0-16 0,1 1-3 16,0 5-51-16,-8 3 15 0,4 3 36 16,-5 4 14-16,-6 6 18 0,6 4-6 15,-1 4 3-15,-1-3 7 0,11-1-1 16,3-6 29-16,-1 0 23 0,7 0 9 15,0 0-19-15,0 1 13 0,0-4-7 16,7-2 13-16,-1-6-26 0,0 0-10 16,11 1-15-16,-2 2-26 0,4-2-19 0,7-1 2 15,2-5-1-15,8-1 0 0,-5-3 12 16,11 0-10-16,-3-7-3 0,-5-3-15 16,1-4-23-16,0-4-7 0,0-4 14 15,-7-5-8-15,2-1-8 0,-12-2-1 16,-9 5-16-16,-5 1 13 0,-1 4 0 15,-3 3 48-15,0 5 3 0,0 2 1 16,0 0 1-16,-7 0 14 0,-2 1 0 0,0 1-13 16,-4 2 0-16,-7 3 0 0,8 0-3 15,-7 0-19-15,1 3-10 0,-6 0-19 16,12 0-25-16,0 0 5 0,2 0-6 16,4 0-29-16,3 0-45 0,3-1-65 15,0-3-105-15,0-2-162 0,0-7-204 16,9-8 84-16</inkml:trace>
+  <inkml:trace contextRef="#ctx0" brushRef="#br0" timeOffset="5607.23">9978 6746 20 0,'0'0'32'0,"0"0"1"0,0 0 35 0,0 0 340 0,0 0 9 0,0 0-238 0,0 0 10 0,0 0 36 0,0 0-69 0,0 0-49 0,-95-7-10 0,89 7 17 0,3 0-20 0,-3 0-23 0,-2 0 4 0,2 0-7 0,0 0-16 0,-4 0-7 0,1 3-3 0,-3 0-13 0,-5 1-3 0,1 2-4 0,-6 0-18 0,-1 0 8 0,2 1-9 0,2 0-1 0,-4 1 33 0,4 4-25 0,-6 4-10 0,-4 5 0 0,-5 6-1 0,1 3 0 0,8-1 0 0,5-1 1 0,11-6 1 0,0 3 31 0,5-1 20 0,4 1-30 0,0-1 4 0,0 0-7 0,13 0 30 0,2 0-14 0,9-5 0 0,-3-5-9 0,-2-3-7 0,10-3 4 0,16 4-23 0,13-3 1 0,8-5 1 0,1-4-1 0,0-6 0 0,-4-10 18 0,1-4-19 0,-4-2-54 0,-5-5-49 0,-10 1-64 0,-14 0 15 0,-8 0 65 0,-11 0 19 0,-12-1 17 0,0-1 51 0,-9 2 16 0,-17-5-3 0,-2 2 19 0,-11 1 17 0,-6 1 22 0,-2 4-6 0,-7 3-11 0,0 2-5 0,3 8-30 0,12 3-16 0,11 3-3 0,2 2-2 0,-2 2-20 0,-2 0 2 0,-1 0-15 0,5 3-46 0,7 2-74 0,4-1-26 0,6 0-24 0,2-3-84 0,7 1-284 0,0-2-52 0,0-3 237 0</inkml:trace>
+  <inkml:trace contextRef="#ctx0" brushRef="#br0" timeOffset="7379.06">10576 7600 121 0,'0'0'322'0,"0"0"-123"0,0 0-150 0,0 0-49 0,0 0 52 0,0 0 23 0,0 0 4 0,0 0 54 0,0 0-68 0,-79 38-52 0,79-37 0 0,0-1-10 0,0 0-3 0,-3 0 42 0,-3-4 615 0,0-1-400 0,-3 0-69 0,1 2-10 0,2 0-52 0,-1 3-126 0,4 0 0 0,-3 0-65 0,0 0-13 0,0 0-25 0,-4 2 32 0,1-1 29 0,-2-1 42 0,5 0 27 0,3 0 31 0,0 0 0 0,3 0-19 0,0 0 6 0,0-1 4 0,0-1-4 0,0 2 0 0,0 0-32 0,0 0-13 0,0 0-68 0,15 0 36 0,12 0 32 0,4 6 39 0,20 3-17 0,12-1 4 0,15 1-10 0,-2-2 7 0,-6-2 38 0,-1-1 23 0,1-2-10 0,11 0 13 0,-2-1 22 0,3-1-23 0,11 1-16 0,3-1-2 0,2 0-5 0,4 0 14 0,4 0-4 0,1 0-32 0,1 0-25 0,-6-2-13 0,1-1 19 0,-9 0-9 0,2 3-11 0,7 0-2 0,-6 0 3 0,6 0 10 0,-1 6-12 0,-1 0 12 0,1-1 3 0,-6 2-4 0,-4 1 1 0,-5 0-10 0,-5 2 16 0,0 0 6 0,-5 2-24 0,-1-2 3 0,-3 1 33 0,-6 1-2 0,-3 1-34 0,-1-1 12 0,-2 1-13 0,-4-2 11 0,-12-1-11 0,-13-5-15 0,-7 1-17 0,-6-2-50 0,4-1-23 0,-4 0 4 0,-1 0 2 0,-1-3-41 0,-4 2-49 0,2-2-10 0,1 0 51 0,1 0 29 0,-2 0-14 0,-2 2-38 0,-1 3-50 0,-9 0-91 0,3 4-101 0,-6-2-72 0,4 7-56 0</inkml:trace>
+  <inkml:trace contextRef="#ctx0" brushRef="#br0" timeOffset="13577.14">15269 7003 39 0,'0'0'163'0,"0"0"-91"0,0 0-53 0,0 0 259 0,0 0 915 0,0 0-778 0,0 0-43 0,3-10-82 0,-3 10-107 0,0 0-71 0,0 0-6 16,0 0 18-16,0 0 16 0,0 0-17 15,0 0-40-15,0 0-83 0,0 0-29 0,0 0-189 16,0 0-242-16,0 0-554 0,4 0-110 16,-8 0 257-16</inkml:trace>
+  <inkml:trace contextRef="#ctx0" brushRef="#br0" timeOffset="15492.3">15759 6338 24 0,'0'0'91'0,"0"0"-88"0,0 0 89 0,0 0-47 0,0 0-32 0,0 0 115 0,0 0 419 0,0 0-32 0,0 0-141 0,25-1-150 0,-25 1-72 0,0 0-32 0,0 0-26 0,0 2-26 0,-3 4 51 0,-3 2 46 0,-4 0-24 0,4 2-29 0,-3 2-35 0,-2-2-54 0,5 0-23 0,0-2-10 0,-1 2 7 0,1-2-13 0,0 3-84 0,-3-1-41 0,-1 0-78 0,0 0 0 0,3 0-102 0,1 2-91 0,0-2-90 0,-3-2-35 0,-4-1-14 0</inkml:trace>
+  <inkml:trace contextRef="#ctx0" brushRef="#br0" timeOffset="15946.2">15572 6868 101 0,'0'0'52'16,"0"0"2011"-16,0 0-1289 0,0 0-314 15,0 0-188-15,0 0-36 0,0 0 6 16,0 0-21-16,0 0-73 0,0 0-74 16,9 3-25-16,-6-3-18 0,-3 0-13 15,0 0-2-15,0 0-4 0,0 0 3 16,0 0 7-16,0 0 3 0,0 0-25 16,0 0-16-16,0 0-36 0,0 0-19 15,0 0 7-15,0 0-1 0,0 0-3 16,0 0 0-16,0 0 0 0,0 0 9 0,0 0 9 15,0 0 0-15,0 0-12 0,0 2-23 16,0-2 28-16,0 1 22 0,0-1-2 16,0 0-29-16,3 0-16 0,-3 0-7 15,3 0-15-15,0 0-80 0,0 0-180 16,1 0-119-16,2 0-142 0,0 0-552 16,-3-13 427-16,-34 25 750 0</inkml:trace>
+  <inkml:trace contextRef="#ctx0" brushRef="#br0" timeOffset="16346.05">16288 6516 2479 0,'0'0'361'0,"0"0"-136"0,0 0-27 0,0 0 15 0,0 0-89 0,0 0-42 16,0 0-34-16,0 0 15 0,0 0-51 0,0 0-12 16,53-73-85-16,-53 73-162 15,4 0-113-15,-1 0-277 0,7 0-385 0,-4 0 41 16</inkml:trace>
+</inkml:ink>
+</file>
+
+<file path=ppt/ink/ink3.xml><?xml version="1.0" encoding="utf-8"?>
+<inkml:ink xmlns:inkml="http://www.w3.org/2003/InkML">
+  <inkml:definitions>
+    <inkml:context xml:id="ctx0">
+      <inkml:inkSource xml:id="inkSrc0">
+        <inkml:traceFormat>
+          <inkml:channel name="X" type="integer" max="32767" units="cm"/>
+          <inkml:channel name="Y" type="integer" max="32767" units="cm"/>
+          <inkml:channel name="F" type="integer" max="8191" units="deg"/>
+          <inkml:channel name="T" type="integer" max="2.14748E9" units="dev"/>
+        </inkml:traceFormat>
+        <inkml:channelProperties>
+          <inkml:channelProperty channel="X" name="resolution" value="2053.07007" units="1/cm"/>
+          <inkml:channelProperty channel="Y" name="resolution" value="3286.55957" units="1/cm"/>
+          <inkml:channelProperty channel="F" name="resolution" value="22.75278" units="1/deg"/>
+          <inkml:channelProperty channel="T" name="resolution" value="1" units="1/dev"/>
+        </inkml:channelProperties>
+      </inkml:inkSource>
+      <inkml:timestamp xml:id="ts0" timeString="2025-11-07T14:00:46.013"/>
+    </inkml:context>
+    <inkml:brush xml:id="br0">
+      <inkml:brushProperty name="width" value="0.05292" units="cm"/>
+      <inkml:brushProperty name="height" value="0.05292" units="cm"/>
+      <inkml:brushProperty name="color" value="#FF0000"/>
+    </inkml:brush>
+  </inkml:definitions>
+  <inkml:trace contextRef="#ctx0" brushRef="#br0">1152 7568 395 0,'0'0'495'15,"0"0"-228"-15,0 0-62 0,0 0-29 0,0 0-20 16,0 0 4-16,0 0-11 0,0 0-19 16,-73-15-33-16,67 9-39 0,3 1 13 15,0 1-35-15,0-1-15 0,-1 2-21 16,4 2-1-16,0 1 1 0,-3 0-13 16,3 0-25-16,0 0-17 0,0 0-13 0,0 0-7 15,0 0 13-15,0 1 62 0,3 2 37 16,4 2-1-16,2-3-10 0,0 3 22 15,7 0 27-15,7 0-30 0,-1 0 4 16,10 1-17-16,-4-2-3 0,11-1 0 16,1 2 29-16,18-4-6 0,13-1-17 15,2-1 4-15,3-7-10 0,-3 1 32 0,4 0 0 16,5 1-6-16,0 2-13 16,2 0 28-16,-2 1-22 0,-6 0-22 0,8 2 3 15,-5-1-10-15,0 2-2 0,-1 0-17 16,-2 0-3-16,-3 0 3 0,-1 3-3 15,9 3 0-15,-5-1-1 0,0 3-23 16,5-4 27-16,-5 1 0 0,-4 0-4 16,-5-1 3-16,3 0 0 0,-7-2 1 15,-2 1 0-15,2-3 23 0,3 0-11 16,-3 0-8-16,1 0-4 0,-1-3 1 0,4 1 8 16,-4-3-9-16,1 2-22 0,0 2-32 15,-4-4-7-15,-6 4-13 0,-3-2-35 16,1 0 31-16,-9 2 8 0,5 1 5 15,-6 0-9-15,-11 0-13 0,-2 1-4 16,-7 3-3-16,11 2-9 0,-5 3-21 16,7-1-96-16,-7 3-80 0,2-5-54 0,-12 1-135 15,-5-7-7-15</inkml:trace>
+  <inkml:trace contextRef="#ctx0" brushRef="#br0" timeOffset="2484.34">1067 8928 32 0,'0'0'632'0,"0"0"-224"0,0 0-119 15,0 0-119-15,0 0-31 0,0 0-2 0,0 0 12 16,0 0 4-16,0 0-1 15,-7 11-13-15,7-11-3 0,0 0 6 0,0 0 3 16,0 0-4-16,0 0-6 0,0 0-30 16,0 0-41-16,0 0-41 0,0 0-21 15,0-1 0-15,0 1 1 0,0 0-3 16,0 0-3-16,0 0-13 0,0 0-3 16,0 0 0-16,0 0-10 0,0 0-16 15,0 0-16-15,7 0-6 0,8 2 67 16,18 4 3-16,36 3 74 0,35 3 19 0,31-4 9 15,8-2-12-15,4-3-14 0,-10-2-28 16,-1 1-26-16,0-2-3 0,5 0 4 16,-10 0-1-16,-4 0-23 0,-6 0 33 15,-10-3-17-15,-8 1-18 0,-21 2-3 16,-12 0-10-16,-22 0-28 0,-13 0-7 16,-13 0-24-16,-3 2 5 0,7-1 13 0,5 1 0 15,23 2-20-15,10 2 55 0,9-1-3 16,7 5-29-16,-7-1-39 0,-9 3-3 15,-1 3-3-15,-5 0-39 0,-4 0-33 16,-3 0-106-16,-17-5-252 0,-4-5-128 16,-15-5-89-16</inkml:trace>
+</inkml:ink>
 </file>
 
 <file path=ppt/notesMasters/notesMaster1.xml><?xml version="1.0" encoding="utf-8"?>
@@ -20037,6 +20144,57 @@
           </a:p>
         </p:txBody>
       </p:sp>
+      <mc:AlternateContent xmlns:mc="http://schemas.openxmlformats.org/markup-compatibility/2006">
+        <mc:Choice xmlns:p14="http://schemas.microsoft.com/office/powerpoint/2010/main" Requires="p14">
+          <p:contentPart p14:bwMode="auto" r:id="rId3">
+            <p14:nvContentPartPr>
+              <p14:cNvPr id="2" name="Ink 1">
+                <a:extLst>
+                  <a:ext uri="{FF2B5EF4-FFF2-40B4-BE49-F238E27FC236}">
+                    <a16:creationId xmlns:a16="http://schemas.microsoft.com/office/drawing/2014/main" id="{E3B8C6D1-AC04-0E01-A4F5-DC2E5575EDC0}"/>
+                  </a:ext>
+                </a:extLst>
+              </p14:cNvPr>
+              <p14:cNvContentPartPr/>
+              <p14:nvPr/>
+            </p14:nvContentPartPr>
+            <p14:xfrm>
+              <a:off x="2877120" y="1621800"/>
+              <a:ext cx="3582360" cy="1677600"/>
+            </p14:xfrm>
+          </p:contentPart>
+        </mc:Choice>
+        <mc:Fallback>
+          <p:pic>
+            <p:nvPicPr>
+              <p:cNvPr id="2" name="Ink 1">
+                <a:extLst>
+                  <a:ext uri="{FF2B5EF4-FFF2-40B4-BE49-F238E27FC236}">
+                    <a16:creationId xmlns:a16="http://schemas.microsoft.com/office/drawing/2014/main" id="{E3B8C6D1-AC04-0E01-A4F5-DC2E5575EDC0}"/>
+                  </a:ext>
+                </a:extLst>
+              </p:cNvPr>
+              <p:cNvPicPr/>
+              <p:nvPr/>
+            </p:nvPicPr>
+            <p:blipFill>
+              <a:blip r:embed="rId4"/>
+              <a:stretch>
+                <a:fillRect/>
+              </a:stretch>
+            </p:blipFill>
+            <p:spPr>
+              <a:xfrm>
+                <a:off x="2867760" y="1612440"/>
+                <a:ext cx="3601080" cy="1696320"/>
+              </a:xfrm>
+              <a:prstGeom prst="rect">
+                <a:avLst/>
+              </a:prstGeom>
+            </p:spPr>
+          </p:pic>
+        </mc:Fallback>
+      </mc:AlternateContent>
     </p:spTree>
   </p:cSld>
   <p:clrMapOvr>
@@ -21550,6 +21708,57 @@
           </a:p>
         </p:txBody>
       </p:sp>
+      <mc:AlternateContent xmlns:mc="http://schemas.openxmlformats.org/markup-compatibility/2006">
+        <mc:Choice xmlns:p14="http://schemas.microsoft.com/office/powerpoint/2010/main" Requires="p14">
+          <p:contentPart p14:bwMode="auto" r:id="rId3">
+            <p14:nvContentPartPr>
+              <p14:cNvPr id="2" name="Ink 1">
+                <a:extLst>
+                  <a:ext uri="{FF2B5EF4-FFF2-40B4-BE49-F238E27FC236}">
+                    <a16:creationId xmlns:a16="http://schemas.microsoft.com/office/drawing/2014/main" id="{43493095-D293-1F62-E3C0-541D602B4CD5}"/>
+                  </a:ext>
+                </a:extLst>
+              </p14:cNvPr>
+              <p14:cNvContentPartPr/>
+              <p14:nvPr/>
+            </p14:nvContentPartPr>
+            <p14:xfrm>
+              <a:off x="2736360" y="2281320"/>
+              <a:ext cx="3155040" cy="561960"/>
+            </p14:xfrm>
+          </p:contentPart>
+        </mc:Choice>
+        <mc:Fallback>
+          <p:pic>
+            <p:nvPicPr>
+              <p:cNvPr id="2" name="Ink 1">
+                <a:extLst>
+                  <a:ext uri="{FF2B5EF4-FFF2-40B4-BE49-F238E27FC236}">
+                    <a16:creationId xmlns:a16="http://schemas.microsoft.com/office/drawing/2014/main" id="{43493095-D293-1F62-E3C0-541D602B4CD5}"/>
+                  </a:ext>
+                </a:extLst>
+              </p:cNvPr>
+              <p:cNvPicPr/>
+              <p:nvPr/>
+            </p:nvPicPr>
+            <p:blipFill>
+              <a:blip r:embed="rId4"/>
+              <a:stretch>
+                <a:fillRect/>
+              </a:stretch>
+            </p:blipFill>
+            <p:spPr>
+              <a:xfrm>
+                <a:off x="2727000" y="2271960"/>
+                <a:ext cx="3173760" cy="580680"/>
+              </a:xfrm>
+              <a:prstGeom prst="rect">
+                <a:avLst/>
+              </a:prstGeom>
+            </p:spPr>
+          </p:pic>
+        </mc:Fallback>
+      </mc:AlternateContent>
     </p:spTree>
   </p:cSld>
   <p:clrMapOvr>
@@ -23717,6 +23926,57 @@
           </a:p>
         </p:txBody>
       </p:sp>
+      <mc:AlternateContent xmlns:mc="http://schemas.openxmlformats.org/markup-compatibility/2006">
+        <mc:Choice xmlns:p14="http://schemas.microsoft.com/office/powerpoint/2010/main" Requires="p14">
+          <p:contentPart p14:bwMode="auto" r:id="rId3">
+            <p14:nvContentPartPr>
+              <p14:cNvPr id="2" name="Ink 1">
+                <a:extLst>
+                  <a:ext uri="{FF2B5EF4-FFF2-40B4-BE49-F238E27FC236}">
+                    <a16:creationId xmlns:a16="http://schemas.microsoft.com/office/drawing/2014/main" id="{376C7D5D-A131-E31B-D02B-C426AB9EF5F3}"/>
+                  </a:ext>
+                </a:extLst>
+              </p14:cNvPr>
+              <p14:cNvContentPartPr/>
+              <p14:nvPr/>
+            </p14:nvContentPartPr>
+            <p14:xfrm>
+              <a:off x="380520" y="2710440"/>
+              <a:ext cx="1267560" cy="568800"/>
+            </p14:xfrm>
+          </p:contentPart>
+        </mc:Choice>
+        <mc:Fallback>
+          <p:pic>
+            <p:nvPicPr>
+              <p:cNvPr id="2" name="Ink 1">
+                <a:extLst>
+                  <a:ext uri="{FF2B5EF4-FFF2-40B4-BE49-F238E27FC236}">
+                    <a16:creationId xmlns:a16="http://schemas.microsoft.com/office/drawing/2014/main" id="{376C7D5D-A131-E31B-D02B-C426AB9EF5F3}"/>
+                  </a:ext>
+                </a:extLst>
+              </p:cNvPr>
+              <p:cNvPicPr/>
+              <p:nvPr/>
+            </p:nvPicPr>
+            <p:blipFill>
+              <a:blip r:embed="rId4"/>
+              <a:stretch>
+                <a:fillRect/>
+              </a:stretch>
+            </p:blipFill>
+            <p:spPr>
+              <a:xfrm>
+                <a:off x="371160" y="2701080"/>
+                <a:ext cx="1286280" cy="587520"/>
+              </a:xfrm>
+              <a:prstGeom prst="rect">
+                <a:avLst/>
+              </a:prstGeom>
+            </p:spPr>
+          </p:pic>
+        </mc:Fallback>
+      </mc:AlternateContent>
     </p:spTree>
   </p:cSld>
   <p:clrMapOvr>

</xml_diff>